<commit_message>
small changes. New chapters.
</commit_message>
<xml_diff>
--- a/slides/Lecture02.pptx
+++ b/slides/Lecture02.pptx
@@ -7,7 +7,7 @@
   <p:sldIdLst>
     <p:sldId id="256" r:id="rId2"/>
     <p:sldId id="353" r:id="rId3"/>
-    <p:sldId id="347" r:id="rId4"/>
+    <p:sldId id="381" r:id="rId4"/>
     <p:sldId id="354" r:id="rId5"/>
     <p:sldId id="355" r:id="rId6"/>
     <p:sldId id="356" r:id="rId7"/>
@@ -127,7 +127,7 @@
           <p14:sldIdLst>
             <p14:sldId id="256"/>
             <p14:sldId id="353"/>
-            <p14:sldId id="347"/>
+            <p14:sldId id="381"/>
             <p14:sldId id="354"/>
             <p14:sldId id="355"/>
             <p14:sldId id="356"/>
@@ -300,7 +300,7 @@
           <a:p>
             <a:fld id="{3E22BF2E-04DA-469E-97C5-BB68A0368813}" type="datetimeFigureOut">
               <a:rPr lang="en-US" smtClean="0"/>
-              <a:t>9/16/2025</a:t>
+              <a:t>9/18/2025</a:t>
             </a:fld>
             <a:endParaRPr lang="en-US"/>
           </a:p>
@@ -498,7 +498,7 @@
           <a:p>
             <a:fld id="{3E22BF2E-04DA-469E-97C5-BB68A0368813}" type="datetimeFigureOut">
               <a:rPr lang="en-US" smtClean="0"/>
-              <a:t>9/16/2025</a:t>
+              <a:t>9/18/2025</a:t>
             </a:fld>
             <a:endParaRPr lang="en-US"/>
           </a:p>
@@ -706,7 +706,7 @@
           <a:p>
             <a:fld id="{3E22BF2E-04DA-469E-97C5-BB68A0368813}" type="datetimeFigureOut">
               <a:rPr lang="en-US" smtClean="0"/>
-              <a:t>9/16/2025</a:t>
+              <a:t>9/18/2025</a:t>
             </a:fld>
             <a:endParaRPr lang="en-US"/>
           </a:p>
@@ -914,7 +914,7 @@
           <a:p>
             <a:fld id="{3E22BF2E-04DA-469E-97C5-BB68A0368813}" type="datetimeFigureOut">
               <a:rPr lang="en-US" smtClean="0"/>
-              <a:t>9/16/2025</a:t>
+              <a:t>9/18/2025</a:t>
             </a:fld>
             <a:endParaRPr lang="en-US"/>
           </a:p>
@@ -1189,7 +1189,7 @@
           <a:p>
             <a:fld id="{3E22BF2E-04DA-469E-97C5-BB68A0368813}" type="datetimeFigureOut">
               <a:rPr lang="en-US" smtClean="0"/>
-              <a:t>9/16/2025</a:t>
+              <a:t>9/18/2025</a:t>
             </a:fld>
             <a:endParaRPr lang="en-US"/>
           </a:p>
@@ -1454,7 +1454,7 @@
           <a:p>
             <a:fld id="{3E22BF2E-04DA-469E-97C5-BB68A0368813}" type="datetimeFigureOut">
               <a:rPr lang="en-US" smtClean="0"/>
-              <a:t>9/16/2025</a:t>
+              <a:t>9/18/2025</a:t>
             </a:fld>
             <a:endParaRPr lang="en-US"/>
           </a:p>
@@ -1866,7 +1866,7 @@
           <a:p>
             <a:fld id="{3E22BF2E-04DA-469E-97C5-BB68A0368813}" type="datetimeFigureOut">
               <a:rPr lang="en-US" smtClean="0"/>
-              <a:t>9/16/2025</a:t>
+              <a:t>9/18/2025</a:t>
             </a:fld>
             <a:endParaRPr lang="en-US"/>
           </a:p>
@@ -2007,7 +2007,7 @@
           <a:p>
             <a:fld id="{3E22BF2E-04DA-469E-97C5-BB68A0368813}" type="datetimeFigureOut">
               <a:rPr lang="en-US" smtClean="0"/>
-              <a:t>9/16/2025</a:t>
+              <a:t>9/18/2025</a:t>
             </a:fld>
             <a:endParaRPr lang="en-US"/>
           </a:p>
@@ -2120,7 +2120,7 @@
           <a:p>
             <a:fld id="{3E22BF2E-04DA-469E-97C5-BB68A0368813}" type="datetimeFigureOut">
               <a:rPr lang="en-US" smtClean="0"/>
-              <a:t>9/16/2025</a:t>
+              <a:t>9/18/2025</a:t>
             </a:fld>
             <a:endParaRPr lang="en-US"/>
           </a:p>
@@ -2431,7 +2431,7 @@
           <a:p>
             <a:fld id="{3E22BF2E-04DA-469E-97C5-BB68A0368813}" type="datetimeFigureOut">
               <a:rPr lang="en-US" smtClean="0"/>
-              <a:t>9/16/2025</a:t>
+              <a:t>9/18/2025</a:t>
             </a:fld>
             <a:endParaRPr lang="en-US"/>
           </a:p>
@@ -2719,7 +2719,7 @@
           <a:p>
             <a:fld id="{3E22BF2E-04DA-469E-97C5-BB68A0368813}" type="datetimeFigureOut">
               <a:rPr lang="en-US" smtClean="0"/>
-              <a:t>9/16/2025</a:t>
+              <a:t>9/18/2025</a:t>
             </a:fld>
             <a:endParaRPr lang="en-US"/>
           </a:p>
@@ -2960,7 +2960,7 @@
           <a:p>
             <a:fld id="{3E22BF2E-04DA-469E-97C5-BB68A0368813}" type="datetimeFigureOut">
               <a:rPr lang="en-US" smtClean="0"/>
-              <a:t>9/16/2025</a:t>
+              <a:t>9/18/2025</a:t>
             </a:fld>
             <a:endParaRPr lang="en-US"/>
           </a:p>
@@ -3995,8 +3995,8 @@
           </a:p>
         </p:txBody>
       </p:sp>
-      <mc:AlternateContent xmlns:mc="http://schemas.openxmlformats.org/markup-compatibility/2006">
-        <mc:Choice xmlns:a14="http://schemas.microsoft.com/office/drawing/2010/main" Requires="a14">
+      <mc:AlternateContent xmlns:mc="http://schemas.openxmlformats.org/markup-compatibility/2006" xmlns:a14="http://schemas.microsoft.com/office/drawing/2010/main">
+        <mc:Choice Requires="a14">
           <p:sp>
             <p:nvSpPr>
               <p:cNvPr id="3" name="Content Placeholder 2">
@@ -4289,7 +4289,7 @@
             </p:txBody>
           </p:sp>
         </mc:Choice>
-        <mc:Fallback>
+        <mc:Fallback xmlns="">
           <p:sp>
             <p:nvSpPr>
               <p:cNvPr id="3" name="Content Placeholder 2">
@@ -12836,7 +12836,7 @@
           <a:p>
             <a:r>
               <a:rPr lang="en-US" dirty="0"/>
-              <a:t>Notation</a:t>
+              <a:t>Summary of Notation</a:t>
             </a:r>
           </a:p>
         </p:txBody>
@@ -12861,8 +12861,8 @@
             </p:nvSpPr>
             <p:spPr>
               <a:xfrm>
-                <a:off x="6211475" y="1124346"/>
-                <a:ext cx="5273179" cy="1505259"/>
+                <a:off x="6211474" y="1140632"/>
+                <a:ext cx="5273179" cy="2049857"/>
               </a:xfrm>
             </p:spPr>
             <p:style>
@@ -12881,9 +12881,27 @@
             </p:style>
             <p:txBody>
               <a:bodyPr>
-                <a:noAutofit/>
+                <a:spAutoFit/>
               </a:bodyPr>
               <a:lstStyle/>
+              <a:p>
+                <a:pPr marL="0" indent="0">
+                  <a:lnSpc>
+                    <a:spcPct val="100000"/>
+                  </a:lnSpc>
+                  <a:spcBef>
+                    <a:spcPts val="0"/>
+                  </a:spcBef>
+                  <a:buNone/>
+                </a:pPr>
+                <a:r>
+                  <a:rPr lang="en-US" sz="1200" b="1" dirty="0"/>
+                  <a:t>Value Function</a:t>
+                </a:r>
+                <a:endParaRPr lang="en-US" sz="1200" i="1" dirty="0">
+                  <a:latin typeface="Cambria Math" panose="02040503050406030204" pitchFamily="18" charset="0"/>
+                </a:endParaRPr>
+              </a:p>
               <a:p>
                 <a:pPr marL="0" indent="0">
                   <a:lnSpc>
@@ -12951,150 +12969,110 @@
                 </a:pPr>
                 <a14:m>
                   <m:oMath xmlns:m="http://schemas.openxmlformats.org/officeDocument/2006/math">
-                    <m:r>
-                      <a:rPr lang="en-US" sz="1200" i="1" dirty="0">
-                        <a:latin typeface="Cambria Math" panose="02040503050406030204" pitchFamily="18" charset="0"/>
-                      </a:rPr>
-                      <m:t>𝑝</m:t>
-                    </m:r>
-                    <m:d>
-                      <m:dPr>
-                        <m:endChr m:val="|"/>
+                    <m:sSub>
+                      <m:sSubPr>
                         <m:ctrlPr>
                           <a:rPr lang="en-US" sz="1200" i="1" dirty="0">
+                            <a:solidFill>
+                              <a:schemeClr val="tx1"/>
+                            </a:solidFill>
                             <a:latin typeface="Cambria Math" panose="02040503050406030204" pitchFamily="18" charset="0"/>
                           </a:rPr>
                         </m:ctrlPr>
-                      </m:dPr>
+                      </m:sSubPr>
                       <m:e>
                         <m:r>
-                          <a:rPr lang="en-US" sz="1200" b="0" i="1" dirty="0" smtClean="0">
+                          <a:rPr lang="en-US" sz="1200" i="1" dirty="0">
+                            <a:solidFill>
+                              <a:schemeClr val="tx1"/>
+                            </a:solidFill>
                             <a:latin typeface="Cambria Math" panose="02040503050406030204" pitchFamily="18" charset="0"/>
                           </a:rPr>
-                          <m:t>𝑠</m:t>
+                          <m:t>𝐺</m:t>
+                        </m:r>
+                      </m:e>
+                      <m:sub>
+                        <m:r>
+                          <a:rPr lang="en-US" sz="1200" i="1" dirty="0">
+                            <a:solidFill>
+                              <a:schemeClr val="tx1"/>
+                            </a:solidFill>
+                            <a:latin typeface="Cambria Math" panose="02040503050406030204" pitchFamily="18" charset="0"/>
+                          </a:rPr>
+                          <m:t>𝑡</m:t>
                         </m:r>
                         <m:r>
-                          <a:rPr lang="en-US" sz="1200" b="0" i="1" dirty="0" smtClean="0">
+                          <a:rPr lang="en-US" sz="1200" i="1" dirty="0">
+                            <a:solidFill>
+                              <a:schemeClr val="tx1"/>
+                            </a:solidFill>
                             <a:latin typeface="Cambria Math" panose="02040503050406030204" pitchFamily="18" charset="0"/>
                           </a:rPr>
-                          <m:t>′ </m:t>
+                          <m:t>:</m:t>
                         </m:r>
-                      </m:e>
-                    </m:d>
-                    <m:r>
-                      <a:rPr lang="en-US" sz="1200" i="1" dirty="0">
-                        <a:latin typeface="Cambria Math" panose="02040503050406030204" pitchFamily="18" charset="0"/>
-                      </a:rPr>
-                      <m:t>𝑠</m:t>
-                    </m:r>
-                    <m:r>
-                      <a:rPr lang="en-US" sz="1200" i="1" dirty="0">
-                        <a:latin typeface="Cambria Math" panose="02040503050406030204" pitchFamily="18" charset="0"/>
-                      </a:rPr>
-                      <m:t>, </m:t>
-                    </m:r>
-                    <m:r>
-                      <a:rPr lang="en-US" sz="1200" i="1" dirty="0">
-                        <a:latin typeface="Cambria Math" panose="02040503050406030204" pitchFamily="18" charset="0"/>
-                      </a:rPr>
-                      <m:t>𝑎</m:t>
-                    </m:r>
-                    <m:r>
-                      <a:rPr lang="en-US" sz="1200" i="1" dirty="0">
-                        <a:latin typeface="Cambria Math" panose="02040503050406030204" pitchFamily="18" charset="0"/>
-                      </a:rPr>
-                      <m:t>)</m:t>
-                    </m:r>
+                        <m:r>
+                          <a:rPr lang="en-US" sz="1200" i="1" dirty="0">
+                            <a:solidFill>
+                              <a:schemeClr val="tx1"/>
+                            </a:solidFill>
+                            <a:latin typeface="Cambria Math" panose="02040503050406030204" pitchFamily="18" charset="0"/>
+                          </a:rPr>
+                          <m:t>h</m:t>
+                        </m:r>
+                      </m:sub>
+                    </m:sSub>
                   </m:oMath>
                 </a14:m>
                 <a:r>
-                  <a:rPr lang="en-US" sz="1200" dirty="0"/>
-                  <a:t>	probability of transition to state </a:t>
+                  <a:rPr lang="en-US" sz="1200" dirty="0">
+                    <a:solidFill>
+                      <a:schemeClr val="tx1"/>
+                    </a:solidFill>
+                  </a:rPr>
+                  <a:t>	return from </a:t>
                 </a:r>
                 <a14:m>
                   <m:oMath xmlns:m="http://schemas.openxmlformats.org/officeDocument/2006/math">
                     <m:r>
-                      <a:rPr lang="en-US" sz="1200" b="0" i="1" dirty="0" smtClean="0">
-                        <a:latin typeface="Cambria Math" panose="02040503050406030204" pitchFamily="18" charset="0"/>
-                      </a:rPr>
-                      <m:t>𝑠</m:t>
-                    </m:r>
-                    <m:r>
-                      <a:rPr lang="en-US" sz="1200" b="0" i="1" dirty="0" smtClean="0">
-                        <a:latin typeface="Cambria Math" panose="02040503050406030204" pitchFamily="18" charset="0"/>
-                      </a:rPr>
-                      <m:t>′</m:t>
+                      <a:rPr lang="en-US" sz="1200" i="1" dirty="0">
+                        <a:solidFill>
+                          <a:schemeClr val="tx1"/>
+                        </a:solidFill>
+                        <a:latin typeface="Cambria Math" panose="02040503050406030204" pitchFamily="18" charset="0"/>
+                      </a:rPr>
+                      <m:t>𝑡</m:t>
                     </m:r>
                   </m:oMath>
                 </a14:m>
                 <a:r>
-                  <a:rPr lang="en-US" sz="1200" dirty="0"/>
-                  <a:t>, from state </a:t>
+                  <a:rPr lang="en-US" sz="1200" dirty="0">
+                    <a:solidFill>
+                      <a:schemeClr val="tx1"/>
+                    </a:solidFill>
+                  </a:rPr>
+                  <a:t> to </a:t>
                 </a:r>
                 <a14:m>
                   <m:oMath xmlns:m="http://schemas.openxmlformats.org/officeDocument/2006/math">
                     <m:r>
                       <a:rPr lang="en-US" sz="1200" i="1" dirty="0">
-                        <a:latin typeface="Cambria Math" panose="02040503050406030204" pitchFamily="18" charset="0"/>
-                      </a:rPr>
-                      <m:t>𝑠</m:t>
+                        <a:solidFill>
+                          <a:schemeClr val="tx1"/>
+                        </a:solidFill>
+                        <a:latin typeface="Cambria Math" panose="02040503050406030204" pitchFamily="18" charset="0"/>
+                      </a:rPr>
+                      <m:t>h</m:t>
                     </m:r>
                   </m:oMath>
                 </a14:m>
                 <a:r>
-                  <a:rPr lang="en-US" sz="1200" dirty="0"/>
-                  <a:t> taking action </a:t>
-                </a:r>
-                <a14:m>
-                  <m:oMath xmlns:m="http://schemas.openxmlformats.org/officeDocument/2006/math">
-                    <m:r>
-                      <a:rPr lang="en-US" sz="1200" i="1" dirty="0" smtClean="0">
-                        <a:latin typeface="Cambria Math" panose="02040503050406030204" pitchFamily="18" charset="0"/>
-                      </a:rPr>
-                      <m:t>𝑎</m:t>
-                    </m:r>
-                  </m:oMath>
-                </a14:m>
-                <a:endParaRPr lang="en-US" sz="1200" dirty="0"/>
-              </a:p>
-              <a:p>
-                <a:pPr marL="0" indent="0">
-                  <a:lnSpc>
-                    <a:spcPct val="100000"/>
-                  </a:lnSpc>
-                  <a:spcBef>
-                    <a:spcPts val="0"/>
-                  </a:spcBef>
-                  <a:buNone/>
-                </a:pPr>
-                <a:r>
-                  <a:rPr lang="en-US" sz="1200" dirty="0"/>
-                  <a:t>	expected immediate reward from state </a:t>
-                </a:r>
-                <a14:m>
-                  <m:oMath xmlns:m="http://schemas.openxmlformats.org/officeDocument/2006/math">
-                    <m:r>
-                      <a:rPr lang="en-US" sz="1200" i="1" dirty="0">
-                        <a:latin typeface="Cambria Math" panose="02040503050406030204" pitchFamily="18" charset="0"/>
-                      </a:rPr>
-                      <m:t>𝑠</m:t>
-                    </m:r>
-                  </m:oMath>
-                </a14:m>
-                <a:r>
-                  <a:rPr lang="en-US" sz="1200" dirty="0"/>
-                  <a:t> after action </a:t>
-                </a:r>
-                <a14:m>
-                  <m:oMath xmlns:m="http://schemas.openxmlformats.org/officeDocument/2006/math">
-                    <m:r>
-                      <a:rPr lang="en-US" sz="1200" i="1" dirty="0">
-                        <a:latin typeface="Cambria Math" panose="02040503050406030204" pitchFamily="18" charset="0"/>
-                      </a:rPr>
-                      <m:t>𝑎</m:t>
-                    </m:r>
-                  </m:oMath>
-                </a14:m>
+                  <a:rPr lang="en-US" sz="1200" dirty="0">
+                    <a:solidFill>
+                      <a:schemeClr val="tx1"/>
+                    </a:solidFill>
+                  </a:rPr>
+                  <a:t> (discounted and corrected)</a:t>
+                </a:r>
                 <a:endParaRPr lang="en-US" sz="1200" dirty="0"/>
               </a:p>
               <a:p>
@@ -13464,6 +13442,550 @@
                   <a:t> under the optimal policy</a:t>
                 </a:r>
               </a:p>
+              <a:p>
+                <a:pPr marL="0" indent="0">
+                  <a:spcBef>
+                    <a:spcPts val="0"/>
+                  </a:spcBef>
+                  <a:buNone/>
+                </a:pPr>
+                <a14:m>
+                  <m:oMath xmlns:m="http://schemas.openxmlformats.org/officeDocument/2006/math">
+                    <m:r>
+                      <a:rPr lang="en-US" sz="1200" i="1" dirty="0">
+                        <a:solidFill>
+                          <a:schemeClr val="tx1"/>
+                        </a:solidFill>
+                        <a:latin typeface="Cambria Math" panose="02040503050406030204" pitchFamily="18" charset="0"/>
+                      </a:rPr>
+                      <m:t>𝑉</m:t>
+                    </m:r>
+                    <m:r>
+                      <a:rPr lang="en-US" sz="1200" i="1" dirty="0">
+                        <a:solidFill>
+                          <a:schemeClr val="tx1"/>
+                        </a:solidFill>
+                        <a:latin typeface="Cambria Math" panose="02040503050406030204" pitchFamily="18" charset="0"/>
+                      </a:rPr>
+                      <m:t>, </m:t>
+                    </m:r>
+                    <m:sSub>
+                      <m:sSubPr>
+                        <m:ctrlPr>
+                          <a:rPr lang="en-US" sz="1200" i="1" dirty="0">
+                            <a:solidFill>
+                              <a:schemeClr val="tx1"/>
+                            </a:solidFill>
+                            <a:latin typeface="Cambria Math" panose="02040503050406030204" pitchFamily="18" charset="0"/>
+                          </a:rPr>
+                        </m:ctrlPr>
+                      </m:sSubPr>
+                      <m:e>
+                        <m:r>
+                          <a:rPr lang="en-US" sz="1200" i="1" dirty="0">
+                            <a:solidFill>
+                              <a:schemeClr val="tx1"/>
+                            </a:solidFill>
+                            <a:latin typeface="Cambria Math" panose="02040503050406030204" pitchFamily="18" charset="0"/>
+                          </a:rPr>
+                          <m:t>𝑉</m:t>
+                        </m:r>
+                      </m:e>
+                      <m:sub>
+                        <m:r>
+                          <a:rPr lang="en-US" sz="1200" i="1" dirty="0">
+                            <a:solidFill>
+                              <a:schemeClr val="tx1"/>
+                            </a:solidFill>
+                            <a:latin typeface="Cambria Math" panose="02040503050406030204" pitchFamily="18" charset="0"/>
+                          </a:rPr>
+                          <m:t>𝑡</m:t>
+                        </m:r>
+                      </m:sub>
+                    </m:sSub>
+                    <m:r>
+                      <a:rPr lang="en-US" sz="1200" i="1" dirty="0">
+                        <a:solidFill>
+                          <a:schemeClr val="tx1"/>
+                        </a:solidFill>
+                        <a:latin typeface="Cambria Math" panose="02040503050406030204" pitchFamily="18" charset="0"/>
+                      </a:rPr>
+                      <m:t> </m:t>
+                    </m:r>
+                  </m:oMath>
+                </a14:m>
+                <a:r>
+                  <a:rPr lang="en-US" sz="1200" dirty="0">
+                    <a:solidFill>
+                      <a:schemeClr val="tx1"/>
+                    </a:solidFill>
+                  </a:rPr>
+                  <a:t>	array estimates of state-value function </a:t>
+                </a:r>
+                <a14:m>
+                  <m:oMath xmlns:m="http://schemas.openxmlformats.org/officeDocument/2006/math">
+                    <m:sSub>
+                      <m:sSubPr>
+                        <m:ctrlPr>
+                          <a:rPr lang="en-US" sz="1200" i="1" dirty="0">
+                            <a:solidFill>
+                              <a:schemeClr val="tx1"/>
+                            </a:solidFill>
+                            <a:latin typeface="Cambria Math" panose="02040503050406030204" pitchFamily="18" charset="0"/>
+                          </a:rPr>
+                        </m:ctrlPr>
+                      </m:sSubPr>
+                      <m:e>
+                        <m:r>
+                          <a:rPr lang="en-US" sz="1200" i="1" dirty="0">
+                            <a:solidFill>
+                              <a:schemeClr val="tx1"/>
+                            </a:solidFill>
+                            <a:latin typeface="Cambria Math" panose="02040503050406030204" pitchFamily="18" charset="0"/>
+                          </a:rPr>
+                          <m:t>𝑣</m:t>
+                        </m:r>
+                      </m:e>
+                      <m:sub>
+                        <m:r>
+                          <a:rPr lang="en-US" sz="1200" i="1" dirty="0">
+                            <a:solidFill>
+                              <a:schemeClr val="tx1"/>
+                            </a:solidFill>
+                            <a:latin typeface="Cambria Math" panose="02040503050406030204" pitchFamily="18" charset="0"/>
+                          </a:rPr>
+                          <m:t>𝜋</m:t>
+                        </m:r>
+                      </m:sub>
+                    </m:sSub>
+                    <m:r>
+                      <a:rPr lang="en-US" sz="1200" i="1" dirty="0">
+                        <a:solidFill>
+                          <a:schemeClr val="tx1"/>
+                        </a:solidFill>
+                        <a:latin typeface="Cambria Math" panose="02040503050406030204" pitchFamily="18" charset="0"/>
+                      </a:rPr>
+                      <m:t> </m:t>
+                    </m:r>
+                  </m:oMath>
+                </a14:m>
+                <a:r>
+                  <a:rPr lang="en-US" sz="1200" dirty="0">
+                    <a:solidFill>
+                      <a:schemeClr val="tx1"/>
+                    </a:solidFill>
+                  </a:rPr>
+                  <a:t>or </a:t>
+                </a:r>
+                <a14:m>
+                  <m:oMath xmlns:m="http://schemas.openxmlformats.org/officeDocument/2006/math">
+                    <m:sSub>
+                      <m:sSubPr>
+                        <m:ctrlPr>
+                          <a:rPr lang="en-US" sz="1200" i="1" dirty="0">
+                            <a:solidFill>
+                              <a:schemeClr val="tx1"/>
+                            </a:solidFill>
+                            <a:latin typeface="Cambria Math" panose="02040503050406030204" pitchFamily="18" charset="0"/>
+                          </a:rPr>
+                        </m:ctrlPr>
+                      </m:sSubPr>
+                      <m:e>
+                        <m:r>
+                          <a:rPr lang="en-US" sz="1200" i="1" dirty="0">
+                            <a:solidFill>
+                              <a:schemeClr val="tx1"/>
+                            </a:solidFill>
+                            <a:latin typeface="Cambria Math" panose="02040503050406030204" pitchFamily="18" charset="0"/>
+                          </a:rPr>
+                          <m:t>𝑣</m:t>
+                        </m:r>
+                      </m:e>
+                      <m:sub>
+                        <m:r>
+                          <a:rPr lang="en-US" sz="1200" i="1" dirty="0">
+                            <a:solidFill>
+                              <a:schemeClr val="tx1"/>
+                            </a:solidFill>
+                            <a:latin typeface="Cambria Math" panose="02040503050406030204" pitchFamily="18" charset="0"/>
+                          </a:rPr>
+                          <m:t>∗</m:t>
+                        </m:r>
+                      </m:sub>
+                    </m:sSub>
+                    <m:r>
+                      <a:rPr lang="en-US" sz="1200" i="1" dirty="0">
+                        <a:solidFill>
+                          <a:schemeClr val="tx1"/>
+                        </a:solidFill>
+                        <a:latin typeface="Cambria Math" panose="02040503050406030204" pitchFamily="18" charset="0"/>
+                      </a:rPr>
+                      <m:t> </m:t>
+                    </m:r>
+                  </m:oMath>
+                </a14:m>
+                <a:endParaRPr lang="en-US" sz="1200" dirty="0">
+                  <a:solidFill>
+                    <a:schemeClr val="tx1"/>
+                  </a:solidFill>
+                </a:endParaRPr>
+              </a:p>
+              <a:p>
+                <a:pPr marL="0" indent="0">
+                  <a:spcBef>
+                    <a:spcPts val="0"/>
+                  </a:spcBef>
+                  <a:buNone/>
+                </a:pPr>
+                <a14:m>
+                  <m:oMath xmlns:m="http://schemas.openxmlformats.org/officeDocument/2006/math">
+                    <m:r>
+                      <a:rPr lang="en-US" sz="1200" i="1" dirty="0">
+                        <a:solidFill>
+                          <a:schemeClr val="tx1"/>
+                        </a:solidFill>
+                        <a:latin typeface="Cambria Math" panose="02040503050406030204" pitchFamily="18" charset="0"/>
+                      </a:rPr>
+                      <m:t>𝑄</m:t>
+                    </m:r>
+                    <m:r>
+                      <a:rPr lang="en-US" sz="1200" i="1" dirty="0">
+                        <a:solidFill>
+                          <a:schemeClr val="tx1"/>
+                        </a:solidFill>
+                        <a:latin typeface="Cambria Math" panose="02040503050406030204" pitchFamily="18" charset="0"/>
+                      </a:rPr>
+                      <m:t>,</m:t>
+                    </m:r>
+                    <m:sSub>
+                      <m:sSubPr>
+                        <m:ctrlPr>
+                          <a:rPr lang="en-US" sz="1200" i="1" dirty="0">
+                            <a:solidFill>
+                              <a:schemeClr val="tx1"/>
+                            </a:solidFill>
+                            <a:latin typeface="Cambria Math" panose="02040503050406030204" pitchFamily="18" charset="0"/>
+                          </a:rPr>
+                        </m:ctrlPr>
+                      </m:sSubPr>
+                      <m:e>
+                        <m:r>
+                          <a:rPr lang="en-US" sz="1200" i="1" dirty="0">
+                            <a:solidFill>
+                              <a:schemeClr val="tx1"/>
+                            </a:solidFill>
+                            <a:latin typeface="Cambria Math" panose="02040503050406030204" pitchFamily="18" charset="0"/>
+                          </a:rPr>
+                          <m:t>𝑄</m:t>
+                        </m:r>
+                      </m:e>
+                      <m:sub>
+                        <m:r>
+                          <a:rPr lang="en-US" sz="1200" i="1" dirty="0">
+                            <a:solidFill>
+                              <a:schemeClr val="tx1"/>
+                            </a:solidFill>
+                            <a:latin typeface="Cambria Math" panose="02040503050406030204" pitchFamily="18" charset="0"/>
+                          </a:rPr>
+                          <m:t>𝑡</m:t>
+                        </m:r>
+                      </m:sub>
+                    </m:sSub>
+                    <m:r>
+                      <a:rPr lang="en-US" sz="1200" i="1" dirty="0">
+                        <a:solidFill>
+                          <a:schemeClr val="tx1"/>
+                        </a:solidFill>
+                        <a:latin typeface="Cambria Math" panose="02040503050406030204" pitchFamily="18" charset="0"/>
+                      </a:rPr>
+                      <m:t> </m:t>
+                    </m:r>
+                  </m:oMath>
+                </a14:m>
+                <a:r>
+                  <a:rPr lang="en-US" sz="1200" dirty="0">
+                    <a:solidFill>
+                      <a:schemeClr val="tx1"/>
+                    </a:solidFill>
+                  </a:rPr>
+                  <a:t>	array estimates of action-value function </a:t>
+                </a:r>
+                <a14:m>
+                  <m:oMath xmlns:m="http://schemas.openxmlformats.org/officeDocument/2006/math">
+                    <m:sSub>
+                      <m:sSubPr>
+                        <m:ctrlPr>
+                          <a:rPr lang="en-US" sz="1200" i="1" dirty="0">
+                            <a:solidFill>
+                              <a:schemeClr val="tx1"/>
+                            </a:solidFill>
+                            <a:latin typeface="Cambria Math" panose="02040503050406030204" pitchFamily="18" charset="0"/>
+                          </a:rPr>
+                        </m:ctrlPr>
+                      </m:sSubPr>
+                      <m:e>
+                        <m:r>
+                          <a:rPr lang="en-US" sz="1200" i="1" dirty="0">
+                            <a:solidFill>
+                              <a:schemeClr val="tx1"/>
+                            </a:solidFill>
+                            <a:latin typeface="Cambria Math" panose="02040503050406030204" pitchFamily="18" charset="0"/>
+                          </a:rPr>
+                          <m:t>𝑞</m:t>
+                        </m:r>
+                      </m:e>
+                      <m:sub>
+                        <m:r>
+                          <a:rPr lang="en-US" sz="1200" i="1" dirty="0">
+                            <a:solidFill>
+                              <a:schemeClr val="tx1"/>
+                            </a:solidFill>
+                            <a:latin typeface="Cambria Math" panose="02040503050406030204" pitchFamily="18" charset="0"/>
+                          </a:rPr>
+                          <m:t>𝜋</m:t>
+                        </m:r>
+                      </m:sub>
+                    </m:sSub>
+                    <m:r>
+                      <a:rPr lang="en-US" sz="1200" i="1" dirty="0">
+                        <a:solidFill>
+                          <a:schemeClr val="tx1"/>
+                        </a:solidFill>
+                        <a:latin typeface="Cambria Math" panose="02040503050406030204" pitchFamily="18" charset="0"/>
+                      </a:rPr>
+                      <m:t> </m:t>
+                    </m:r>
+                  </m:oMath>
+                </a14:m>
+                <a:r>
+                  <a:rPr lang="en-US" sz="1200" dirty="0">
+                    <a:solidFill>
+                      <a:schemeClr val="tx1"/>
+                    </a:solidFill>
+                  </a:rPr>
+                  <a:t>or </a:t>
+                </a:r>
+                <a14:m>
+                  <m:oMath xmlns:m="http://schemas.openxmlformats.org/officeDocument/2006/math">
+                    <m:sSub>
+                      <m:sSubPr>
+                        <m:ctrlPr>
+                          <a:rPr lang="en-US" sz="1200" i="1" dirty="0">
+                            <a:solidFill>
+                              <a:schemeClr val="tx1"/>
+                            </a:solidFill>
+                            <a:latin typeface="Cambria Math" panose="02040503050406030204" pitchFamily="18" charset="0"/>
+                          </a:rPr>
+                        </m:ctrlPr>
+                      </m:sSubPr>
+                      <m:e>
+                        <m:r>
+                          <a:rPr lang="en-US" sz="1200" i="1" dirty="0">
+                            <a:solidFill>
+                              <a:schemeClr val="tx1"/>
+                            </a:solidFill>
+                            <a:latin typeface="Cambria Math" panose="02040503050406030204" pitchFamily="18" charset="0"/>
+                          </a:rPr>
+                          <m:t>𝑣</m:t>
+                        </m:r>
+                      </m:e>
+                      <m:sub>
+                        <m:r>
+                          <a:rPr lang="en-US" sz="1200" i="1" dirty="0">
+                            <a:solidFill>
+                              <a:schemeClr val="tx1"/>
+                            </a:solidFill>
+                            <a:latin typeface="Cambria Math" panose="02040503050406030204" pitchFamily="18" charset="0"/>
+                          </a:rPr>
+                          <m:t>∗</m:t>
+                        </m:r>
+                      </m:sub>
+                    </m:sSub>
+                  </m:oMath>
+                </a14:m>
+                <a:endParaRPr lang="en-US" sz="1200" dirty="0">
+                  <a:solidFill>
+                    <a:schemeClr val="tx1"/>
+                  </a:solidFill>
+                </a:endParaRPr>
+              </a:p>
+              <a:p>
+                <a:pPr marL="0" indent="0">
+                  <a:spcBef>
+                    <a:spcPts val="0"/>
+                  </a:spcBef>
+                  <a:buNone/>
+                </a:pPr>
+                <a14:m>
+                  <m:oMath xmlns:m="http://schemas.openxmlformats.org/officeDocument/2006/math">
+                    <m:sSub>
+                      <m:sSubPr>
+                        <m:ctrlPr>
+                          <a:rPr lang="en-US" sz="1200" i="1" dirty="0">
+                            <a:solidFill>
+                              <a:schemeClr val="tx1"/>
+                            </a:solidFill>
+                            <a:latin typeface="Cambria Math" panose="02040503050406030204" pitchFamily="18" charset="0"/>
+                          </a:rPr>
+                        </m:ctrlPr>
+                      </m:sSubPr>
+                      <m:e>
+                        <m:acc>
+                          <m:accPr>
+                            <m:chr m:val="̅"/>
+                            <m:ctrlPr>
+                              <a:rPr lang="en-US" sz="1200" i="1" dirty="0">
+                                <a:solidFill>
+                                  <a:schemeClr val="tx1"/>
+                                </a:solidFill>
+                                <a:latin typeface="Cambria Math" panose="02040503050406030204" pitchFamily="18" charset="0"/>
+                              </a:rPr>
+                            </m:ctrlPr>
+                          </m:accPr>
+                          <m:e>
+                            <m:r>
+                              <a:rPr lang="en-US" sz="1200" i="1" dirty="0">
+                                <a:solidFill>
+                                  <a:schemeClr val="tx1"/>
+                                </a:solidFill>
+                                <a:latin typeface="Cambria Math" panose="02040503050406030204" pitchFamily="18" charset="0"/>
+                              </a:rPr>
+                              <m:t>𝑉</m:t>
+                            </m:r>
+                          </m:e>
+                        </m:acc>
+                      </m:e>
+                      <m:sub>
+                        <m:r>
+                          <a:rPr lang="en-US" sz="1200" i="1" dirty="0">
+                            <a:solidFill>
+                              <a:schemeClr val="tx1"/>
+                            </a:solidFill>
+                            <a:latin typeface="Cambria Math" panose="02040503050406030204" pitchFamily="18" charset="0"/>
+                          </a:rPr>
+                          <m:t>𝑡</m:t>
+                        </m:r>
+                      </m:sub>
+                    </m:sSub>
+                    <m:r>
+                      <a:rPr lang="en-US" sz="1200" i="1" dirty="0">
+                        <a:solidFill>
+                          <a:schemeClr val="tx1"/>
+                        </a:solidFill>
+                        <a:latin typeface="Cambria Math" panose="02040503050406030204" pitchFamily="18" charset="0"/>
+                      </a:rPr>
+                      <m:t>(</m:t>
+                    </m:r>
+                    <m:r>
+                      <a:rPr lang="en-US" sz="1200" i="1" dirty="0">
+                        <a:solidFill>
+                          <a:schemeClr val="tx1"/>
+                        </a:solidFill>
+                        <a:latin typeface="Cambria Math" panose="02040503050406030204" pitchFamily="18" charset="0"/>
+                      </a:rPr>
+                      <m:t>𝑠</m:t>
+                    </m:r>
+                    <m:r>
+                      <a:rPr lang="en-US" sz="1200" i="1" dirty="0">
+                        <a:solidFill>
+                          <a:schemeClr val="tx1"/>
+                        </a:solidFill>
+                        <a:latin typeface="Cambria Math" panose="02040503050406030204" pitchFamily="18" charset="0"/>
+                      </a:rPr>
+                      <m:t>) </m:t>
+                    </m:r>
+                  </m:oMath>
+                </a14:m>
+                <a:r>
+                  <a:rPr lang="en-US" sz="1200" dirty="0">
+                    <a:solidFill>
+                      <a:schemeClr val="tx1"/>
+                    </a:solidFill>
+                  </a:rPr>
+                  <a:t>	expected approximate action value</a:t>
+                </a:r>
+              </a:p>
+              <a:p>
+                <a:pPr marL="0" indent="0">
+                  <a:spcBef>
+                    <a:spcPts val="0"/>
+                  </a:spcBef>
+                  <a:buNone/>
+                </a:pPr>
+                <a14:m>
+                  <m:oMath xmlns:m="http://schemas.openxmlformats.org/officeDocument/2006/math">
+                    <m:sSub>
+                      <m:sSubPr>
+                        <m:ctrlPr>
+                          <a:rPr lang="en-US" sz="1200" i="1" dirty="0">
+                            <a:solidFill>
+                              <a:schemeClr val="tx1"/>
+                            </a:solidFill>
+                            <a:latin typeface="Cambria Math" panose="02040503050406030204" pitchFamily="18" charset="0"/>
+                          </a:rPr>
+                        </m:ctrlPr>
+                      </m:sSubPr>
+                      <m:e>
+                        <m:r>
+                          <a:rPr lang="en-US" sz="1200" i="1" dirty="0">
+                            <a:solidFill>
+                              <a:schemeClr val="tx1"/>
+                            </a:solidFill>
+                            <a:latin typeface="Cambria Math" panose="02040503050406030204" pitchFamily="18" charset="0"/>
+                          </a:rPr>
+                          <m:t>𝑈</m:t>
+                        </m:r>
+                      </m:e>
+                      <m:sub>
+                        <m:r>
+                          <a:rPr lang="en-US" sz="1200" i="1" dirty="0">
+                            <a:solidFill>
+                              <a:schemeClr val="tx1"/>
+                            </a:solidFill>
+                            <a:latin typeface="Cambria Math" panose="02040503050406030204" pitchFamily="18" charset="0"/>
+                          </a:rPr>
+                          <m:t>𝑡</m:t>
+                        </m:r>
+                      </m:sub>
+                    </m:sSub>
+                  </m:oMath>
+                </a14:m>
+                <a:r>
+                  <a:rPr lang="en-US" sz="1200" dirty="0">
+                    <a:solidFill>
+                      <a:schemeClr val="tx1"/>
+                    </a:solidFill>
+                  </a:rPr>
+                  <a:t>	target for estimate at time</a:t>
+                </a:r>
+                <a14:m>
+                  <m:oMath xmlns:m="http://schemas.openxmlformats.org/officeDocument/2006/math">
+                    <m:r>
+                      <a:rPr lang="en-US" sz="1200" i="1" dirty="0">
+                        <a:solidFill>
+                          <a:schemeClr val="tx1"/>
+                        </a:solidFill>
+                        <a:latin typeface="Cambria Math" panose="02040503050406030204" pitchFamily="18" charset="0"/>
+                      </a:rPr>
+                      <m:t> </m:t>
+                    </m:r>
+                    <m:r>
+                      <a:rPr lang="en-US" sz="1200" i="1" dirty="0">
+                        <a:solidFill>
+                          <a:schemeClr val="tx1"/>
+                        </a:solidFill>
+                        <a:latin typeface="Cambria Math" panose="02040503050406030204" pitchFamily="18" charset="0"/>
+                      </a:rPr>
+                      <m:t>𝑡</m:t>
+                    </m:r>
+                  </m:oMath>
+                </a14:m>
+                <a:endParaRPr lang="en-US" sz="1200" dirty="0">
+                  <a:solidFill>
+                    <a:schemeClr val="tx1"/>
+                  </a:solidFill>
+                </a:endParaRPr>
+              </a:p>
             </p:txBody>
           </p:sp>
         </mc:Choice>
@@ -13486,13 +14008,13 @@
             </p:nvSpPr>
             <p:spPr>
               <a:xfrm>
-                <a:off x="6211475" y="1124346"/>
-                <a:ext cx="5273179" cy="1505259"/>
+                <a:off x="6211474" y="1140632"/>
+                <a:ext cx="5273179" cy="2049857"/>
               </a:xfrm>
               <a:blipFill>
                 <a:blip r:embed="rId2"/>
                 <a:stretch>
-                  <a:fillRect/>
+                  <a:fillRect b="-885"/>
                 </a:stretch>
               </a:blipFill>
             </p:spPr>
@@ -13515,10 +14037,671 @@
         <mc:Choice Requires="a14">
           <p:sp>
             <p:nvSpPr>
-              <p:cNvPr id="6" name="Content Placeholder 2">
+              <p:cNvPr id="10" name="TextBox 9">
                 <a:extLst>
                   <a:ext uri="{FF2B5EF4-FFF2-40B4-BE49-F238E27FC236}">
-                    <a16:creationId xmlns:a16="http://schemas.microsoft.com/office/drawing/2014/main" id="{708B36CA-535B-718D-F6EB-D4F59B9D2614}"/>
+                    <a16:creationId xmlns:a16="http://schemas.microsoft.com/office/drawing/2014/main" id="{5CD475E5-BE3B-5594-57DC-46A17411F2F9}"/>
+                  </a:ext>
+                </a:extLst>
+              </p:cNvPr>
+              <p:cNvSpPr txBox="1"/>
+              <p:nvPr/>
+            </p:nvSpPr>
+            <p:spPr>
+              <a:xfrm>
+                <a:off x="822820" y="1124198"/>
+                <a:ext cx="5273179" cy="2308324"/>
+              </a:xfrm>
+              <a:prstGeom prst="rect">
+                <a:avLst/>
+              </a:prstGeom>
+            </p:spPr>
+            <p:style>
+              <a:lnRef idx="2">
+                <a:schemeClr val="accent2"/>
+              </a:lnRef>
+              <a:fillRef idx="1">
+                <a:schemeClr val="lt1"/>
+              </a:fillRef>
+              <a:effectRef idx="0">
+                <a:schemeClr val="accent2"/>
+              </a:effectRef>
+              <a:fontRef idx="minor">
+                <a:schemeClr val="dk1"/>
+              </a:fontRef>
+            </p:style>
+            <p:txBody>
+              <a:bodyPr wrap="square">
+                <a:spAutoFit/>
+              </a:bodyPr>
+              <a:lstStyle/>
+              <a:p>
+                <a:r>
+                  <a:rPr lang="en-US" sz="1200" b="1" dirty="0"/>
+                  <a:t>General</a:t>
+                </a:r>
+                <a:endParaRPr lang="en-US" sz="1200" dirty="0"/>
+              </a:p>
+              <a:p>
+                <a14:m>
+                  <m:oMath xmlns:m="http://schemas.openxmlformats.org/officeDocument/2006/math">
+                    <m:r>
+                      <a:rPr lang="en-US" sz="1200" i="1" dirty="0" smtClean="0">
+                        <a:latin typeface="Cambria Math" panose="02040503050406030204" pitchFamily="18" charset="0"/>
+                      </a:rPr>
+                      <m:t>𝑋</m:t>
+                    </m:r>
+                  </m:oMath>
+                </a14:m>
+                <a:r>
+                  <a:rPr lang="en-US" sz="1200" dirty="0"/>
+                  <a:t>	capital letters: random variables</a:t>
+                </a:r>
+                <a:br>
+                  <a:rPr lang="en-US" sz="1200" dirty="0"/>
+                </a:br>
+                <a14:m>
+                  <m:oMath xmlns:m="http://schemas.openxmlformats.org/officeDocument/2006/math">
+                    <m:r>
+                      <a:rPr lang="en-US" sz="1200" b="0" i="1" smtClean="0">
+                        <a:latin typeface="Cambria Math" panose="02040503050406030204" pitchFamily="18" charset="0"/>
+                      </a:rPr>
+                      <m:t>𝑥</m:t>
+                    </m:r>
+                    <m:r>
+                      <a:rPr lang="en-US" sz="1200" b="0" i="0" smtClean="0">
+                        <a:latin typeface="Cambria Math" panose="02040503050406030204" pitchFamily="18" charset="0"/>
+                      </a:rPr>
+                      <m:t>, </m:t>
+                    </m:r>
+                    <m:r>
+                      <a:rPr lang="en-US" sz="1200" b="0" i="1" smtClean="0">
+                        <a:latin typeface="Cambria Math" panose="02040503050406030204" pitchFamily="18" charset="0"/>
+                      </a:rPr>
+                      <m:t>𝑝</m:t>
+                    </m:r>
+                  </m:oMath>
+                </a14:m>
+                <a:r>
+                  <a:rPr lang="en-US" sz="1200" dirty="0"/>
+                  <a:t>	lower-case letters: realizations of random variables </a:t>
+                </a:r>
+                <a:br>
+                  <a:rPr lang="en-US" sz="1200" dirty="0"/>
+                </a:br>
+                <a:r>
+                  <a:rPr lang="en-US" sz="1200" dirty="0"/>
+                  <a:t>	or scalar functions</a:t>
+                </a:r>
+              </a:p>
+              <a:p>
+                <a14:m>
+                  <m:oMath xmlns:m="http://schemas.openxmlformats.org/officeDocument/2006/math">
+                    <m:r>
+                      <a:rPr lang="en-US" sz="1200" b="1" i="1" smtClean="0">
+                        <a:latin typeface="Cambria Math" panose="02040503050406030204" pitchFamily="18" charset="0"/>
+                      </a:rPr>
+                      <m:t>𝒘</m:t>
+                    </m:r>
+                  </m:oMath>
+                </a14:m>
+                <a:r>
+                  <a:rPr lang="en-US" sz="1200" dirty="0"/>
+                  <a:t> 	Bold lower-case letters: real-valued vectors </a:t>
+                </a:r>
+                <a:br>
+                  <a:rPr lang="en-US" sz="1200" dirty="0"/>
+                </a:br>
+                <a:r>
+                  <a:rPr lang="en-US" sz="1200" dirty="0"/>
+                  <a:t>	(even if random variables)</a:t>
+                </a:r>
+              </a:p>
+              <a:p>
+                <a14:m>
+                  <m:oMath xmlns:m="http://schemas.openxmlformats.org/officeDocument/2006/math">
+                    <m:r>
+                      <a:rPr lang="en-US" sz="1200" b="1" i="1" smtClean="0">
+                        <a:latin typeface="Cambria Math" panose="02040503050406030204" pitchFamily="18" charset="0"/>
+                      </a:rPr>
+                      <m:t>𝑾</m:t>
+                    </m:r>
+                  </m:oMath>
+                </a14:m>
+                <a:r>
+                  <a:rPr lang="en-US" sz="1200" dirty="0"/>
+                  <a:t>	bold capitals: matrices</a:t>
+                </a:r>
+              </a:p>
+              <a:p>
+                <a14:m>
+                  <m:oMath xmlns:m="http://schemas.openxmlformats.org/officeDocument/2006/math">
+                    <m:r>
+                      <a:rPr lang="en-US" sz="1200" b="0" i="1" smtClean="0">
+                        <a:latin typeface="Cambria Math" panose="02040503050406030204" pitchFamily="18" charset="0"/>
+                      </a:rPr>
+                      <m:t>𝛼</m:t>
+                    </m:r>
+                  </m:oMath>
+                </a14:m>
+                <a:r>
+                  <a:rPr lang="en-US" sz="1200" dirty="0"/>
+                  <a:t>	Greek letters: parameters (vectors if in bolt)</a:t>
+                </a:r>
+              </a:p>
+              <a:p>
+                <a14:m>
+                  <m:oMath xmlns:m="http://schemas.openxmlformats.org/officeDocument/2006/math">
+                    <m:r>
+                      <m:rPr>
+                        <m:sty m:val="p"/>
+                      </m:rPr>
+                      <a:rPr lang="en-US" sz="1200" i="1" dirty="0">
+                        <a:latin typeface="Cambria Math" panose="02040503050406030204" pitchFamily="18" charset="0"/>
+                      </a:rPr>
+                      <m:t>Pr</m:t>
+                    </m:r>
+                    <m:r>
+                      <a:rPr lang="en-US" sz="1200" i="1" dirty="0">
+                        <a:latin typeface="Cambria Math" panose="02040503050406030204" pitchFamily="18" charset="0"/>
+                      </a:rPr>
+                      <m:t>⁡{</m:t>
+                    </m:r>
+                    <m:r>
+                      <a:rPr lang="en-US" sz="1200" i="1" dirty="0">
+                        <a:latin typeface="Cambria Math" panose="02040503050406030204" pitchFamily="18" charset="0"/>
+                      </a:rPr>
+                      <m:t>𝑋</m:t>
+                    </m:r>
+                    <m:r>
+                      <a:rPr lang="en-US" sz="1200" i="1" dirty="0">
+                        <a:latin typeface="Cambria Math" panose="02040503050406030204" pitchFamily="18" charset="0"/>
+                      </a:rPr>
+                      <m:t>=</m:t>
+                    </m:r>
+                    <m:r>
+                      <a:rPr lang="en-US" sz="1200" i="1" dirty="0">
+                        <a:latin typeface="Cambria Math" panose="02040503050406030204" pitchFamily="18" charset="0"/>
+                      </a:rPr>
+                      <m:t>𝑥</m:t>
+                    </m:r>
+                    <m:r>
+                      <a:rPr lang="en-US" sz="1200" i="1" dirty="0">
+                        <a:latin typeface="Cambria Math" panose="02040503050406030204" pitchFamily="18" charset="0"/>
+                      </a:rPr>
+                      <m:t>}</m:t>
+                    </m:r>
+                  </m:oMath>
+                </a14:m>
+                <a:r>
+                  <a:rPr lang="en-US" sz="1200" dirty="0"/>
+                  <a:t>	probability that a random variable </a:t>
+                </a:r>
+                <a14:m>
+                  <m:oMath xmlns:m="http://schemas.openxmlformats.org/officeDocument/2006/math">
+                    <m:r>
+                      <a:rPr lang="en-US" sz="1200" i="1" dirty="0">
+                        <a:latin typeface="Cambria Math" panose="02040503050406030204" pitchFamily="18" charset="0"/>
+                      </a:rPr>
+                      <m:t>𝑋</m:t>
+                    </m:r>
+                  </m:oMath>
+                </a14:m>
+                <a:r>
+                  <a:rPr lang="en-US" sz="1200" dirty="0"/>
+                  <a:t> takes on the value </a:t>
+                </a:r>
+                <a14:m>
+                  <m:oMath xmlns:m="http://schemas.openxmlformats.org/officeDocument/2006/math">
+                    <m:r>
+                      <a:rPr lang="en-US" sz="1200" i="1" dirty="0">
+                        <a:latin typeface="Cambria Math" panose="02040503050406030204" pitchFamily="18" charset="0"/>
+                      </a:rPr>
+                      <m:t>𝑥</m:t>
+                    </m:r>
+                  </m:oMath>
+                </a14:m>
+                <a:endParaRPr lang="en-US" sz="1200" dirty="0"/>
+              </a:p>
+              <a:p>
+                <a14:m>
+                  <m:oMath xmlns:m="http://schemas.openxmlformats.org/officeDocument/2006/math">
+                    <m:r>
+                      <a:rPr lang="en-US" sz="1200" i="1" dirty="0">
+                        <a:latin typeface="Cambria Math" panose="02040503050406030204" pitchFamily="18" charset="0"/>
+                      </a:rPr>
+                      <m:t>𝑋</m:t>
+                    </m:r>
+                    <m:r>
+                      <a:rPr lang="en-US" sz="1200" i="1" dirty="0">
+                        <a:latin typeface="Cambria Math" panose="02040503050406030204" pitchFamily="18" charset="0"/>
+                      </a:rPr>
+                      <m:t>~</m:t>
+                    </m:r>
+                    <m:r>
+                      <a:rPr lang="en-US" sz="1200" i="1" dirty="0">
+                        <a:latin typeface="Cambria Math" panose="02040503050406030204" pitchFamily="18" charset="0"/>
+                      </a:rPr>
+                      <m:t>𝑝</m:t>
+                    </m:r>
+                  </m:oMath>
+                </a14:m>
+                <a:r>
+                  <a:rPr lang="en-US" sz="1200" dirty="0"/>
+                  <a:t>	random variable </a:t>
+                </a:r>
+                <a14:m>
+                  <m:oMath xmlns:m="http://schemas.openxmlformats.org/officeDocument/2006/math">
+                    <m:r>
+                      <a:rPr lang="en-US" sz="1200" i="1" dirty="0">
+                        <a:latin typeface="Cambria Math" panose="02040503050406030204" pitchFamily="18" charset="0"/>
+                      </a:rPr>
+                      <m:t>𝑋</m:t>
+                    </m:r>
+                  </m:oMath>
+                </a14:m>
+                <a:r>
+                  <a:rPr lang="en-US" sz="1200" dirty="0"/>
+                  <a:t> selected from distribution</a:t>
+                </a:r>
+                <a14:m>
+                  <m:oMath xmlns:m="http://schemas.openxmlformats.org/officeDocument/2006/math">
+                    <m:r>
+                      <a:rPr lang="en-US" sz="1200" i="1">
+                        <a:latin typeface="Cambria Math" panose="02040503050406030204" pitchFamily="18" charset="0"/>
+                      </a:rPr>
+                      <m:t>𝑝</m:t>
+                    </m:r>
+                    <m:d>
+                      <m:dPr>
+                        <m:ctrlPr>
+                          <a:rPr lang="en-US" sz="1200" i="1">
+                            <a:latin typeface="Cambria Math" panose="02040503050406030204" pitchFamily="18" charset="0"/>
+                          </a:rPr>
+                        </m:ctrlPr>
+                      </m:dPr>
+                      <m:e>
+                        <m:r>
+                          <a:rPr lang="en-US" sz="1200" i="1">
+                            <a:latin typeface="Cambria Math" panose="02040503050406030204" pitchFamily="18" charset="0"/>
+                          </a:rPr>
+                          <m:t>𝑥</m:t>
+                        </m:r>
+                      </m:e>
+                    </m:d>
+                    <m:r>
+                      <a:rPr lang="en-US" sz="1200" i="1">
+                        <a:latin typeface="Cambria Math" panose="02040503050406030204" pitchFamily="18" charset="0"/>
+                      </a:rPr>
+                      <m:t>=</m:t>
+                    </m:r>
+                    <m:r>
+                      <m:rPr>
+                        <m:sty m:val="p"/>
+                      </m:rPr>
+                      <a:rPr lang="en-US" sz="1200">
+                        <a:latin typeface="Cambria Math" panose="02040503050406030204" pitchFamily="18" charset="0"/>
+                      </a:rPr>
+                      <m:t>Pr</m:t>
+                    </m:r>
+                    <m:r>
+                      <a:rPr lang="en-US" sz="1200" i="1">
+                        <a:latin typeface="Cambria Math" panose="02040503050406030204" pitchFamily="18" charset="0"/>
+                      </a:rPr>
+                      <m:t>⁡{</m:t>
+                    </m:r>
+                    <m:r>
+                      <a:rPr lang="en-US" sz="1200" i="1">
+                        <a:latin typeface="Cambria Math" panose="02040503050406030204" pitchFamily="18" charset="0"/>
+                      </a:rPr>
+                      <m:t>𝑋</m:t>
+                    </m:r>
+                    <m:r>
+                      <a:rPr lang="en-US" sz="1200" i="1">
+                        <a:latin typeface="Cambria Math" panose="02040503050406030204" pitchFamily="18" charset="0"/>
+                      </a:rPr>
+                      <m:t>=</m:t>
+                    </m:r>
+                    <m:r>
+                      <a:rPr lang="en-US" sz="1200" i="1">
+                        <a:latin typeface="Cambria Math" panose="02040503050406030204" pitchFamily="18" charset="0"/>
+                      </a:rPr>
+                      <m:t>𝑥</m:t>
+                    </m:r>
+                    <m:r>
+                      <a:rPr lang="en-US" sz="1200" i="1">
+                        <a:latin typeface="Cambria Math" panose="02040503050406030204" pitchFamily="18" charset="0"/>
+                      </a:rPr>
+                      <m:t>}</m:t>
+                    </m:r>
+                  </m:oMath>
+                </a14:m>
+                <a:endParaRPr lang="en-US" sz="1200" dirty="0"/>
+              </a:p>
+              <a:p>
+                <a14:m>
+                  <m:oMath xmlns:m="http://schemas.openxmlformats.org/officeDocument/2006/math">
+                    <m:r>
+                      <a:rPr lang="en-US" sz="1200" i="1">
+                        <a:latin typeface="Cambria Math" panose="02040503050406030204" pitchFamily="18" charset="0"/>
+                        <a:ea typeface="Cambria Math" panose="02040503050406030204" pitchFamily="18" charset="0"/>
+                      </a:rPr>
+                      <m:t>𝔼</m:t>
+                    </m:r>
+                    <m:r>
+                      <a:rPr lang="en-US" sz="1200" i="1">
+                        <a:latin typeface="Cambria Math" panose="02040503050406030204" pitchFamily="18" charset="0"/>
+                        <a:ea typeface="Cambria Math" panose="02040503050406030204" pitchFamily="18" charset="0"/>
+                      </a:rPr>
+                      <m:t>[</m:t>
+                    </m:r>
+                    <m:r>
+                      <a:rPr lang="en-US" sz="1200" i="1">
+                        <a:latin typeface="Cambria Math" panose="02040503050406030204" pitchFamily="18" charset="0"/>
+                        <a:ea typeface="Cambria Math" panose="02040503050406030204" pitchFamily="18" charset="0"/>
+                      </a:rPr>
+                      <m:t>𝑋</m:t>
+                    </m:r>
+                    <m:r>
+                      <a:rPr lang="en-US" sz="1200" i="1">
+                        <a:latin typeface="Cambria Math" panose="02040503050406030204" pitchFamily="18" charset="0"/>
+                        <a:ea typeface="Cambria Math" panose="02040503050406030204" pitchFamily="18" charset="0"/>
+                      </a:rPr>
+                      <m:t>]</m:t>
+                    </m:r>
+                  </m:oMath>
+                </a14:m>
+                <a:r>
+                  <a:rPr lang="en-US" sz="1200" dirty="0"/>
+                  <a:t>	expectation of a random variable </a:t>
+                </a:r>
+                <a14:m>
+                  <m:oMath xmlns:m="http://schemas.openxmlformats.org/officeDocument/2006/math">
+                    <m:r>
+                      <a:rPr lang="en-US" sz="1200" i="1" dirty="0">
+                        <a:latin typeface="Cambria Math" panose="02040503050406030204" pitchFamily="18" charset="0"/>
+                      </a:rPr>
+                      <m:t>𝑋</m:t>
+                    </m:r>
+                  </m:oMath>
+                </a14:m>
+                <a:r>
+                  <a:rPr lang="en-US" sz="1200" dirty="0"/>
+                  <a:t>, i.e.,</a:t>
+                </a:r>
+                <a14:m>
+                  <m:oMath xmlns:m="http://schemas.openxmlformats.org/officeDocument/2006/math">
+                    <m:r>
+                      <a:rPr lang="en-US" sz="1200" i="1">
+                        <a:latin typeface="Cambria Math" panose="02040503050406030204" pitchFamily="18" charset="0"/>
+                        <a:ea typeface="Cambria Math" panose="02040503050406030204" pitchFamily="18" charset="0"/>
+                      </a:rPr>
+                      <m:t>𝔼</m:t>
+                    </m:r>
+                    <m:d>
+                      <m:dPr>
+                        <m:begChr m:val="["/>
+                        <m:endChr m:val="]"/>
+                        <m:ctrlPr>
+                          <a:rPr lang="en-US" sz="1200" i="1">
+                            <a:latin typeface="Cambria Math" panose="02040503050406030204" pitchFamily="18" charset="0"/>
+                            <a:ea typeface="Cambria Math" panose="02040503050406030204" pitchFamily="18" charset="0"/>
+                          </a:rPr>
+                        </m:ctrlPr>
+                      </m:dPr>
+                      <m:e>
+                        <m:r>
+                          <a:rPr lang="en-US" sz="1200" i="1">
+                            <a:latin typeface="Cambria Math" panose="02040503050406030204" pitchFamily="18" charset="0"/>
+                            <a:ea typeface="Cambria Math" panose="02040503050406030204" pitchFamily="18" charset="0"/>
+                          </a:rPr>
+                          <m:t>𝑋</m:t>
+                        </m:r>
+                      </m:e>
+                    </m:d>
+                    <m:r>
+                      <a:rPr lang="en-US" sz="1200" i="1">
+                        <a:latin typeface="Cambria Math" panose="02040503050406030204" pitchFamily="18" charset="0"/>
+                        <a:ea typeface="Cambria Math" panose="02040503050406030204" pitchFamily="18" charset="0"/>
+                      </a:rPr>
+                      <m:t>=</m:t>
+                    </m:r>
+                    <m:nary>
+                      <m:naryPr>
+                        <m:chr m:val="∑"/>
+                        <m:supHide m:val="on"/>
+                        <m:ctrlPr>
+                          <a:rPr lang="en-US" sz="1200" i="1">
+                            <a:latin typeface="Cambria Math" panose="02040503050406030204" pitchFamily="18" charset="0"/>
+                            <a:ea typeface="Cambria Math" panose="02040503050406030204" pitchFamily="18" charset="0"/>
+                          </a:rPr>
+                        </m:ctrlPr>
+                      </m:naryPr>
+                      <m:sub>
+                        <m:r>
+                          <a:rPr lang="en-US" sz="1200" i="1">
+                            <a:latin typeface="Cambria Math" panose="02040503050406030204" pitchFamily="18" charset="0"/>
+                            <a:ea typeface="Cambria Math" panose="02040503050406030204" pitchFamily="18" charset="0"/>
+                          </a:rPr>
+                          <m:t>𝑥</m:t>
+                        </m:r>
+                      </m:sub>
+                      <m:sup/>
+                      <m:e>
+                        <m:r>
+                          <a:rPr lang="en-US" sz="1200" i="1">
+                            <a:latin typeface="Cambria Math" panose="02040503050406030204" pitchFamily="18" charset="0"/>
+                            <a:ea typeface="Cambria Math" panose="02040503050406030204" pitchFamily="18" charset="0"/>
+                          </a:rPr>
+                          <m:t>𝑝</m:t>
+                        </m:r>
+                        <m:d>
+                          <m:dPr>
+                            <m:ctrlPr>
+                              <a:rPr lang="en-US" sz="1200" i="1">
+                                <a:latin typeface="Cambria Math" panose="02040503050406030204" pitchFamily="18" charset="0"/>
+                                <a:ea typeface="Cambria Math" panose="02040503050406030204" pitchFamily="18" charset="0"/>
+                              </a:rPr>
+                            </m:ctrlPr>
+                          </m:dPr>
+                          <m:e>
+                            <m:r>
+                              <a:rPr lang="en-US" sz="1200" i="1">
+                                <a:latin typeface="Cambria Math" panose="02040503050406030204" pitchFamily="18" charset="0"/>
+                                <a:ea typeface="Cambria Math" panose="02040503050406030204" pitchFamily="18" charset="0"/>
+                              </a:rPr>
+                              <m:t>𝑥</m:t>
+                            </m:r>
+                          </m:e>
+                        </m:d>
+                        <m:r>
+                          <a:rPr lang="en-US" sz="1200" i="1">
+                            <a:latin typeface="Cambria Math" panose="02040503050406030204" pitchFamily="18" charset="0"/>
+                            <a:ea typeface="Cambria Math" panose="02040503050406030204" pitchFamily="18" charset="0"/>
+                          </a:rPr>
+                          <m:t>𝑥</m:t>
+                        </m:r>
+                      </m:e>
+                    </m:nary>
+                  </m:oMath>
+                </a14:m>
+                <a:endParaRPr lang="en-US" sz="1200" dirty="0">
+                  <a:ea typeface="Cambria Math" panose="02040503050406030204" pitchFamily="18" charset="0"/>
+                </a:endParaRPr>
+              </a:p>
+              <a:p>
+                <a14:m>
+                  <m:oMath xmlns:m="http://schemas.openxmlformats.org/officeDocument/2006/math">
+                    <m:sSub>
+                      <m:sSubPr>
+                        <m:ctrlPr>
+                          <a:rPr lang="en-US" sz="1200" i="1" dirty="0">
+                            <a:latin typeface="Cambria Math" panose="02040503050406030204" pitchFamily="18" charset="0"/>
+                          </a:rPr>
+                        </m:ctrlPr>
+                      </m:sSubPr>
+                      <m:e>
+                        <m:r>
+                          <m:rPr>
+                            <m:sty m:val="p"/>
+                          </m:rPr>
+                          <a:rPr lang="en-US" sz="1200" dirty="0">
+                            <a:latin typeface="Cambria Math" panose="02040503050406030204" pitchFamily="18" charset="0"/>
+                          </a:rPr>
+                          <m:t>argmax</m:t>
+                        </m:r>
+                      </m:e>
+                      <m:sub>
+                        <m:r>
+                          <m:rPr>
+                            <m:sty m:val="p"/>
+                          </m:rPr>
+                          <a:rPr lang="en-US" sz="1200" dirty="0">
+                            <a:latin typeface="Cambria Math" panose="02040503050406030204" pitchFamily="18" charset="0"/>
+                          </a:rPr>
+                          <m:t>a</m:t>
+                        </m:r>
+                      </m:sub>
+                    </m:sSub>
+                    <m:r>
+                      <a:rPr lang="en-US" sz="1200" dirty="0">
+                        <a:latin typeface="Cambria Math" panose="02040503050406030204" pitchFamily="18" charset="0"/>
+                      </a:rPr>
+                      <m:t> </m:t>
+                    </m:r>
+                    <m:r>
+                      <a:rPr lang="en-US" sz="1200" i="1" dirty="0">
+                        <a:latin typeface="Cambria Math" panose="02040503050406030204" pitchFamily="18" charset="0"/>
+                      </a:rPr>
+                      <m:t>𝑓</m:t>
+                    </m:r>
+                    <m:r>
+                      <a:rPr lang="en-US" sz="1200" i="1" dirty="0">
+                        <a:latin typeface="Cambria Math" panose="02040503050406030204" pitchFamily="18" charset="0"/>
+                      </a:rPr>
+                      <m:t>(</m:t>
+                    </m:r>
+                    <m:r>
+                      <a:rPr lang="en-US" sz="1200" i="1" dirty="0">
+                        <a:latin typeface="Cambria Math" panose="02040503050406030204" pitchFamily="18" charset="0"/>
+                      </a:rPr>
+                      <m:t>𝑎</m:t>
+                    </m:r>
+                    <m:r>
+                      <a:rPr lang="en-US" sz="1200" i="1" dirty="0">
+                        <a:latin typeface="Cambria Math" panose="02040503050406030204" pitchFamily="18" charset="0"/>
+                      </a:rPr>
+                      <m:t>)</m:t>
+                    </m:r>
+                  </m:oMath>
+                </a14:m>
+                <a:r>
+                  <a:rPr lang="en-US" sz="1200" dirty="0"/>
+                  <a:t> a value of action </a:t>
+                </a:r>
+                <a14:m>
+                  <m:oMath xmlns:m="http://schemas.openxmlformats.org/officeDocument/2006/math">
+                    <m:r>
+                      <a:rPr lang="en-US" sz="1200" i="1" dirty="0">
+                        <a:latin typeface="Cambria Math" panose="02040503050406030204" pitchFamily="18" charset="0"/>
+                      </a:rPr>
+                      <m:t>𝑎</m:t>
+                    </m:r>
+                  </m:oMath>
+                </a14:m>
+                <a:r>
+                  <a:rPr lang="en-US" sz="1200" dirty="0"/>
+                  <a:t> at which </a:t>
+                </a:r>
+                <a14:m>
+                  <m:oMath xmlns:m="http://schemas.openxmlformats.org/officeDocument/2006/math">
+                    <m:r>
+                      <a:rPr lang="en-US" sz="1200" i="1" dirty="0">
+                        <a:latin typeface="Cambria Math" panose="02040503050406030204" pitchFamily="18" charset="0"/>
+                      </a:rPr>
+                      <m:t>𝑓</m:t>
+                    </m:r>
+                    <m:r>
+                      <a:rPr lang="en-US" sz="1200" i="1" dirty="0">
+                        <a:latin typeface="Cambria Math" panose="02040503050406030204" pitchFamily="18" charset="0"/>
+                      </a:rPr>
+                      <m:t>(</m:t>
+                    </m:r>
+                    <m:r>
+                      <a:rPr lang="en-US" sz="1200" i="1" dirty="0">
+                        <a:latin typeface="Cambria Math" panose="02040503050406030204" pitchFamily="18" charset="0"/>
+                      </a:rPr>
+                      <m:t>𝑎</m:t>
+                    </m:r>
+                    <m:r>
+                      <a:rPr lang="en-US" sz="1200" i="1" dirty="0">
+                        <a:latin typeface="Cambria Math" panose="02040503050406030204" pitchFamily="18" charset="0"/>
+                      </a:rPr>
+                      <m:t>)</m:t>
+                    </m:r>
+                  </m:oMath>
+                </a14:m>
+                <a:r>
+                  <a:rPr lang="en-US" sz="1200" dirty="0"/>
+                  <a:t> takes its maximal value</a:t>
+                </a:r>
+              </a:p>
+            </p:txBody>
+          </p:sp>
+        </mc:Choice>
+        <mc:Fallback xmlns="">
+          <p:sp>
+            <p:nvSpPr>
+              <p:cNvPr id="10" name="TextBox 9">
+                <a:extLst>
+                  <a:ext uri="{FF2B5EF4-FFF2-40B4-BE49-F238E27FC236}">
+                    <a16:creationId xmlns:a16="http://schemas.microsoft.com/office/drawing/2014/main" id="{5CD475E5-BE3B-5594-57DC-46A17411F2F9}"/>
+                  </a:ext>
+                </a:extLst>
+              </p:cNvPr>
+              <p:cNvSpPr txBox="1">
+                <a:spLocks noRot="1" noChangeAspect="1" noMove="1" noResize="1" noEditPoints="1" noAdjustHandles="1" noChangeArrowheads="1" noChangeShapeType="1" noTextEdit="1"/>
+              </p:cNvSpPr>
+              <p:nvPr/>
+            </p:nvSpPr>
+            <p:spPr>
+              <a:xfrm>
+                <a:off x="822820" y="1124198"/>
+                <a:ext cx="5273179" cy="2308324"/>
+              </a:xfrm>
+              <a:prstGeom prst="rect">
+                <a:avLst/>
+              </a:prstGeom>
+              <a:blipFill>
+                <a:blip r:embed="rId3"/>
+                <a:stretch>
+                  <a:fillRect b="-9424"/>
+                </a:stretch>
+              </a:blipFill>
+            </p:spPr>
+            <p:txBody>
+              <a:bodyPr/>
+              <a:lstStyle/>
+              <a:p>
+                <a:r>
+                  <a:rPr lang="en-US">
+                    <a:noFill/>
+                  </a:rPr>
+                  <a:t> </a:t>
+                </a:r>
+              </a:p>
+            </p:txBody>
+          </p:sp>
+        </mc:Fallback>
+      </mc:AlternateContent>
+      <mc:AlternateContent xmlns:mc="http://schemas.openxmlformats.org/markup-compatibility/2006" xmlns:a14="http://schemas.microsoft.com/office/drawing/2010/main">
+        <mc:Choice Requires="a14">
+          <p:sp>
+            <p:nvSpPr>
+              <p:cNvPr id="11" name="Content Placeholder 2">
+                <a:extLst>
+                  <a:ext uri="{FF2B5EF4-FFF2-40B4-BE49-F238E27FC236}">
+                    <a16:creationId xmlns:a16="http://schemas.microsoft.com/office/drawing/2014/main" id="{6F45EA4F-65F9-5141-0B09-C395CF9CA7A0}"/>
                   </a:ext>
                 </a:extLst>
               </p:cNvPr>
@@ -13529,8 +14712,8 @@
             </p:nvSpPr>
             <p:spPr>
               <a:xfrm>
-                <a:off x="822821" y="2150317"/>
-                <a:ext cx="5273179" cy="958576"/>
+                <a:off x="822819" y="3570646"/>
+                <a:ext cx="5273179" cy="2985823"/>
               </a:xfrm>
               <a:prstGeom prst="rect">
                 <a:avLst/>
@@ -13552,7 +14735,7 @@
             </p:style>
             <p:txBody>
               <a:bodyPr vert="horz" lIns="91440" tIns="45720" rIns="91440" bIns="45720" rtlCol="0">
-                <a:noAutofit/>
+                <a:spAutoFit/>
               </a:bodyPr>
               <a:lstStyle>
                 <a:lvl1pPr marL="228600" indent="-228600" algn="l" defTabSz="914400" rtl="0" eaLnBrk="1" latinLnBrk="0" hangingPunct="1">
@@ -13725,74 +14908,206 @@
                   </a:spcBef>
                   <a:buNone/>
                 </a:pPr>
+                <a:r>
+                  <a:rPr lang="en-US" sz="1200" b="1" dirty="0"/>
+                  <a:t>MDP</a:t>
+                </a:r>
+              </a:p>
+              <a:p>
+                <a:pPr marL="0" indent="0">
+                  <a:spcBef>
+                    <a:spcPts val="0"/>
+                  </a:spcBef>
+                  <a:buNone/>
+                </a:pPr>
                 <a14:m>
                   <m:oMath xmlns:m="http://schemas.openxmlformats.org/officeDocument/2006/math">
                     <m:r>
-                      <m:rPr>
-                        <m:sty m:val="p"/>
-                      </m:rPr>
                       <a:rPr lang="en-US" sz="1200" i="1" dirty="0" smtClean="0">
                         <a:latin typeface="Cambria Math" panose="02040503050406030204" pitchFamily="18" charset="0"/>
                       </a:rPr>
-                      <m:t>Pr</m:t>
-                    </m:r>
-                    <m:r>
-                      <a:rPr lang="en-US" sz="1200" i="1" dirty="0">
-                        <a:latin typeface="Cambria Math" panose="02040503050406030204" pitchFamily="18" charset="0"/>
-                      </a:rPr>
-                      <m:t>⁡{</m:t>
-                    </m:r>
-                    <m:r>
-                      <a:rPr lang="en-US" sz="1200" i="1" dirty="0">
-                        <a:latin typeface="Cambria Math" panose="02040503050406030204" pitchFamily="18" charset="0"/>
-                      </a:rPr>
-                      <m:t>𝑋</m:t>
-                    </m:r>
-                    <m:r>
-                      <a:rPr lang="en-US" sz="1200" i="1" dirty="0">
-                        <a:latin typeface="Cambria Math" panose="02040503050406030204" pitchFamily="18" charset="0"/>
-                      </a:rPr>
-                      <m:t>=</m:t>
-                    </m:r>
-                    <m:r>
-                      <a:rPr lang="en-US" sz="1200" i="1" dirty="0">
-                        <a:latin typeface="Cambria Math" panose="02040503050406030204" pitchFamily="18" charset="0"/>
-                      </a:rPr>
-                      <m:t>𝑥</m:t>
-                    </m:r>
-                    <m:r>
-                      <a:rPr lang="en-US" sz="1200" i="1" dirty="0">
-                        <a:latin typeface="Cambria Math" panose="02040503050406030204" pitchFamily="18" charset="0"/>
-                      </a:rPr>
-                      <m:t>}</m:t>
+                      <m:t>𝑠</m:t>
+                    </m:r>
+                    <m:r>
+                      <a:rPr lang="en-US" sz="1200" i="1" dirty="0" smtClean="0">
+                        <a:latin typeface="Cambria Math" panose="02040503050406030204" pitchFamily="18" charset="0"/>
+                      </a:rPr>
+                      <m:t>, </m:t>
+                    </m:r>
+                    <m:r>
+                      <a:rPr lang="en-US" sz="1200" i="1" dirty="0" smtClean="0">
+                        <a:latin typeface="Cambria Math" panose="02040503050406030204" pitchFamily="18" charset="0"/>
+                      </a:rPr>
+                      <m:t>𝑠</m:t>
+                    </m:r>
+                    <m:r>
+                      <a:rPr lang="en-US" sz="1200" b="0" i="1" dirty="0" smtClean="0">
+                        <a:latin typeface="Cambria Math" panose="02040503050406030204" pitchFamily="18" charset="0"/>
+                      </a:rPr>
+                      <m:t>′</m:t>
                     </m:r>
                   </m:oMath>
                 </a14:m>
                 <a:r>
                   <a:rPr lang="en-US" sz="1200" dirty="0"/>
-                  <a:t>	probability that a random variable </a:t>
-                </a:r>
+                  <a:t> 	states</a:t>
+                </a:r>
+              </a:p>
+              <a:p>
+                <a:pPr marL="0" indent="0">
+                  <a:spcBef>
+                    <a:spcPts val="0"/>
+                  </a:spcBef>
+                  <a:buNone/>
+                </a:pPr>
                 <a14:m>
                   <m:oMath xmlns:m="http://schemas.openxmlformats.org/officeDocument/2006/math">
                     <m:r>
                       <a:rPr lang="en-US" sz="1200" i="1" dirty="0" smtClean="0">
                         <a:latin typeface="Cambria Math" panose="02040503050406030204" pitchFamily="18" charset="0"/>
                       </a:rPr>
-                      <m:t>𝑋</m:t>
+                      <m:t>𝑎</m:t>
                     </m:r>
                   </m:oMath>
                 </a14:m>
                 <a:r>
                   <a:rPr lang="en-US" sz="1200" dirty="0"/>
-                  <a:t> takes on the value </a:t>
-                </a:r>
+                  <a:t> 	an action</a:t>
+                </a:r>
+              </a:p>
+              <a:p>
+                <a:pPr marL="0" indent="0">
+                  <a:spcBef>
+                    <a:spcPts val="0"/>
+                  </a:spcBef>
+                  <a:buNone/>
+                </a:pPr>
                 <a14:m>
                   <m:oMath xmlns:m="http://schemas.openxmlformats.org/officeDocument/2006/math">
                     <m:r>
                       <a:rPr lang="en-US" sz="1200" i="1" dirty="0" smtClean="0">
                         <a:latin typeface="Cambria Math" panose="02040503050406030204" pitchFamily="18" charset="0"/>
                       </a:rPr>
-                      <m:t>𝑥</m:t>
+                      <m:t>𝑟</m:t>
+                    </m:r>
+                  </m:oMath>
+                </a14:m>
+                <a:r>
+                  <a:rPr lang="en-US" sz="1200" dirty="0"/>
+                  <a:t> 	a reward</a:t>
+                </a:r>
+              </a:p>
+              <a:p>
+                <a:pPr marL="0" indent="0">
+                  <a:spcBef>
+                    <a:spcPts val="0"/>
+                  </a:spcBef>
+                  <a:buNone/>
+                </a:pPr>
+                <a14:m>
+                  <m:oMath xmlns:m="http://schemas.openxmlformats.org/officeDocument/2006/math">
+                    <m:r>
+                      <a:rPr lang="en-US" sz="1200" i="1" dirty="0" smtClean="0">
+                        <a:latin typeface="Cambria Math" panose="02040503050406030204" pitchFamily="18" charset="0"/>
+                        <a:ea typeface="Cambria Math" panose="02040503050406030204" pitchFamily="18" charset="0"/>
+                      </a:rPr>
+                      <m:t>𝒮</m:t>
+                    </m:r>
+                  </m:oMath>
+                </a14:m>
+                <a:r>
+                  <a:rPr lang="en-US" sz="1200" dirty="0"/>
+                  <a:t> 	set of all (nonterminal) states, </a:t>
+                </a:r>
+                <a14:m>
+                  <m:oMath xmlns:m="http://schemas.openxmlformats.org/officeDocument/2006/math">
+                    <m:sSup>
+                      <m:sSupPr>
+                        <m:ctrlPr>
+                          <a:rPr lang="en-US" sz="1200" b="0" i="1" dirty="0" smtClean="0">
+                            <a:latin typeface="Cambria Math" panose="02040503050406030204" pitchFamily="18" charset="0"/>
+                            <a:ea typeface="Cambria Math" panose="02040503050406030204" pitchFamily="18" charset="0"/>
+                          </a:rPr>
+                        </m:ctrlPr>
+                      </m:sSupPr>
+                      <m:e>
+                        <m:r>
+                          <a:rPr lang="en-US" sz="1200" i="1" dirty="0">
+                            <a:latin typeface="Cambria Math" panose="02040503050406030204" pitchFamily="18" charset="0"/>
+                            <a:ea typeface="Cambria Math" panose="02040503050406030204" pitchFamily="18" charset="0"/>
+                          </a:rPr>
+                          <m:t>𝒮</m:t>
+                        </m:r>
+                      </m:e>
+                      <m:sup>
+                        <m:r>
+                          <a:rPr lang="en-US" sz="1200" b="0" i="1" dirty="0" smtClean="0">
+                            <a:latin typeface="Cambria Math" panose="02040503050406030204" pitchFamily="18" charset="0"/>
+                            <a:ea typeface="Cambria Math" panose="02040503050406030204" pitchFamily="18" charset="0"/>
+                          </a:rPr>
+                          <m:t>+</m:t>
+                        </m:r>
+                      </m:sup>
+                    </m:sSup>
+                  </m:oMath>
+                </a14:m>
+                <a:r>
+                  <a:rPr lang="en-US" sz="1200" dirty="0"/>
+                  <a:t> are </a:t>
+                </a:r>
+                <a:r>
+                  <a:rPr lang="en-US" sz="1200"/>
+                  <a:t>all states </a:t>
+                </a:r>
+                <a:endParaRPr lang="en-US" sz="1200" dirty="0"/>
+              </a:p>
+              <a:p>
+                <a:pPr marL="0" indent="0">
+                  <a:spcBef>
+                    <a:spcPts val="0"/>
+                  </a:spcBef>
+                  <a:buNone/>
+                </a:pPr>
+                <a14:m>
+                  <m:oMath xmlns:m="http://schemas.openxmlformats.org/officeDocument/2006/math">
+                    <m:r>
+                      <a:rPr lang="en-US" sz="1200" i="1" dirty="0" smtClean="0">
+                        <a:latin typeface="Cambria Math" panose="02040503050406030204" pitchFamily="18" charset="0"/>
+                        <a:ea typeface="Cambria Math" panose="02040503050406030204" pitchFamily="18" charset="0"/>
+                      </a:rPr>
+                      <m:t>𝒜</m:t>
+                    </m:r>
+                    <m:r>
+                      <a:rPr lang="en-US" sz="1200" i="1" dirty="0">
+                        <a:latin typeface="Cambria Math" panose="02040503050406030204" pitchFamily="18" charset="0"/>
+                      </a:rPr>
+                      <m:t>(</m:t>
+                    </m:r>
+                    <m:r>
+                      <a:rPr lang="en-US" sz="1200" i="1" dirty="0">
+                        <a:latin typeface="Cambria Math" panose="02040503050406030204" pitchFamily="18" charset="0"/>
+                      </a:rPr>
+                      <m:t>𝑠</m:t>
+                    </m:r>
+                    <m:r>
+                      <a:rPr lang="en-US" sz="1200" i="1" dirty="0">
+                        <a:latin typeface="Cambria Math" panose="02040503050406030204" pitchFamily="18" charset="0"/>
+                      </a:rPr>
+                      <m:t>)</m:t>
+                    </m:r>
+                  </m:oMath>
+                </a14:m>
+                <a:r>
+                  <a:rPr lang="en-US" sz="1200" dirty="0"/>
+                  <a:t>	set of all actions available in state </a:t>
+                </a:r>
+                <a14:m>
+                  <m:oMath xmlns:m="http://schemas.openxmlformats.org/officeDocument/2006/math">
+                    <m:r>
+                      <a:rPr lang="en-US" sz="1200" i="1" dirty="0" smtClean="0">
+                        <a:latin typeface="Cambria Math" panose="02040503050406030204" pitchFamily="18" charset="0"/>
+                      </a:rPr>
+                      <m:t>𝑠</m:t>
                     </m:r>
                   </m:oMath>
                 </a14:m>
@@ -13808,899 +15123,20 @@
                 <a14:m>
                   <m:oMath xmlns:m="http://schemas.openxmlformats.org/officeDocument/2006/math">
                     <m:r>
-                      <a:rPr lang="en-US" sz="1200" b="0" i="1" dirty="0" smtClean="0">
-                        <a:latin typeface="Cambria Math" panose="02040503050406030204" pitchFamily="18" charset="0"/>
-                      </a:rPr>
-                      <m:t>𝑋</m:t>
-                    </m:r>
-                    <m:r>
-                      <a:rPr lang="en-US" sz="1200" b="0" i="1" dirty="0" smtClean="0">
-                        <a:latin typeface="Cambria Math" panose="02040503050406030204" pitchFamily="18" charset="0"/>
-                      </a:rPr>
-                      <m:t>~</m:t>
-                    </m:r>
-                    <m:r>
-                      <a:rPr lang="en-US" sz="1200" b="0" i="1" dirty="0" smtClean="0">
-                        <a:latin typeface="Cambria Math" panose="02040503050406030204" pitchFamily="18" charset="0"/>
-                      </a:rPr>
-                      <m:t>𝑝</m:t>
+                      <a:rPr lang="en-US" sz="1200" i="1">
+                        <a:latin typeface="Cambria Math" panose="02040503050406030204" pitchFamily="18" charset="0"/>
+                      </a:rPr>
+                      <m:t>𝛾</m:t>
                     </m:r>
                   </m:oMath>
                 </a14:m>
                 <a:r>
                   <a:rPr lang="en-US" sz="1200" dirty="0"/>
-                  <a:t>	random variable </a:t>
-                </a:r>
-                <a14:m>
-                  <m:oMath xmlns:m="http://schemas.openxmlformats.org/officeDocument/2006/math">
-                    <m:r>
-                      <a:rPr lang="en-US" sz="1200" i="1" dirty="0" smtClean="0">
-                        <a:latin typeface="Cambria Math" panose="02040503050406030204" pitchFamily="18" charset="0"/>
-                      </a:rPr>
-                      <m:t>𝑋</m:t>
-                    </m:r>
-                  </m:oMath>
-                </a14:m>
-                <a:r>
-                  <a:rPr lang="en-US" sz="1200" dirty="0"/>
-                  <a:t> selected from distribution</a:t>
-                </a:r>
-                <a14:m>
-                  <m:oMath xmlns:m="http://schemas.openxmlformats.org/officeDocument/2006/math">
-                    <m:r>
-                      <a:rPr lang="en-US" sz="1200" i="1">
-                        <a:latin typeface="Cambria Math" panose="02040503050406030204" pitchFamily="18" charset="0"/>
-                      </a:rPr>
-                      <m:t>𝑝</m:t>
-                    </m:r>
-                    <m:d>
-                      <m:dPr>
-                        <m:ctrlPr>
-                          <a:rPr lang="en-US" sz="1200" i="1">
-                            <a:latin typeface="Cambria Math" panose="02040503050406030204" pitchFamily="18" charset="0"/>
-                          </a:rPr>
-                        </m:ctrlPr>
-                      </m:dPr>
-                      <m:e>
-                        <m:r>
-                          <a:rPr lang="en-US" sz="1200" i="1">
-                            <a:latin typeface="Cambria Math" panose="02040503050406030204" pitchFamily="18" charset="0"/>
-                          </a:rPr>
-                          <m:t>𝑥</m:t>
-                        </m:r>
-                      </m:e>
-                    </m:d>
-                    <m:r>
-                      <a:rPr lang="en-US" sz="1200" i="1">
-                        <a:latin typeface="Cambria Math" panose="02040503050406030204" pitchFamily="18" charset="0"/>
-                      </a:rPr>
-                      <m:t>=</m:t>
-                    </m:r>
-                    <m:r>
-                      <m:rPr>
-                        <m:sty m:val="p"/>
-                      </m:rPr>
-                      <a:rPr lang="en-US" sz="1200">
-                        <a:latin typeface="Cambria Math" panose="02040503050406030204" pitchFamily="18" charset="0"/>
-                      </a:rPr>
-                      <m:t>Pr</m:t>
-                    </m:r>
-                    <m:r>
-                      <a:rPr lang="en-US" sz="1200" i="1">
-                        <a:latin typeface="Cambria Math" panose="02040503050406030204" pitchFamily="18" charset="0"/>
-                      </a:rPr>
-                      <m:t>⁡{</m:t>
-                    </m:r>
-                    <m:r>
-                      <a:rPr lang="en-US" sz="1200" i="1">
-                        <a:latin typeface="Cambria Math" panose="02040503050406030204" pitchFamily="18" charset="0"/>
-                      </a:rPr>
-                      <m:t>𝑋</m:t>
-                    </m:r>
-                    <m:r>
-                      <a:rPr lang="en-US" sz="1200" i="1">
-                        <a:latin typeface="Cambria Math" panose="02040503050406030204" pitchFamily="18" charset="0"/>
-                      </a:rPr>
-                      <m:t>=</m:t>
-                    </m:r>
-                    <m:r>
-                      <a:rPr lang="en-US" sz="1200" i="1">
-                        <a:latin typeface="Cambria Math" panose="02040503050406030204" pitchFamily="18" charset="0"/>
-                      </a:rPr>
-                      <m:t>𝑥</m:t>
-                    </m:r>
-                    <m:r>
-                      <a:rPr lang="en-US" sz="1200" i="1">
-                        <a:latin typeface="Cambria Math" panose="02040503050406030204" pitchFamily="18" charset="0"/>
-                      </a:rPr>
-                      <m:t>}</m:t>
-                    </m:r>
-                  </m:oMath>
-                </a14:m>
-                <a:endParaRPr lang="en-US" sz="1200" dirty="0"/>
-              </a:p>
-              <a:p>
-                <a:pPr marL="0" indent="0">
-                  <a:spcBef>
-                    <a:spcPts val="0"/>
-                  </a:spcBef>
-                  <a:buNone/>
-                </a:pPr>
-                <a14:m>
-                  <m:oMath xmlns:m="http://schemas.openxmlformats.org/officeDocument/2006/math">
-                    <m:r>
-                      <a:rPr lang="en-US" sz="1200" i="1" smtClean="0">
-                        <a:latin typeface="Cambria Math" panose="02040503050406030204" pitchFamily="18" charset="0"/>
-                        <a:ea typeface="Cambria Math" panose="02040503050406030204" pitchFamily="18" charset="0"/>
-                      </a:rPr>
-                      <m:t>𝔼</m:t>
-                    </m:r>
-                    <m:r>
-                      <a:rPr lang="en-US" sz="1200" b="0" i="1" smtClean="0">
-                        <a:latin typeface="Cambria Math" panose="02040503050406030204" pitchFamily="18" charset="0"/>
-                        <a:ea typeface="Cambria Math" panose="02040503050406030204" pitchFamily="18" charset="0"/>
-                      </a:rPr>
-                      <m:t>[</m:t>
-                    </m:r>
-                    <m:r>
-                      <a:rPr lang="en-US" sz="1200" b="0" i="1" smtClean="0">
-                        <a:latin typeface="Cambria Math" panose="02040503050406030204" pitchFamily="18" charset="0"/>
-                        <a:ea typeface="Cambria Math" panose="02040503050406030204" pitchFamily="18" charset="0"/>
-                      </a:rPr>
-                      <m:t>𝑋</m:t>
-                    </m:r>
-                    <m:r>
-                      <a:rPr lang="en-US" sz="1200" b="0" i="1" smtClean="0">
-                        <a:latin typeface="Cambria Math" panose="02040503050406030204" pitchFamily="18" charset="0"/>
-                        <a:ea typeface="Cambria Math" panose="02040503050406030204" pitchFamily="18" charset="0"/>
-                      </a:rPr>
-                      <m:t>]</m:t>
-                    </m:r>
-                  </m:oMath>
-                </a14:m>
-                <a:r>
-                  <a:rPr lang="en-US" sz="1200" dirty="0"/>
-                  <a:t>	expectation of a random variable </a:t>
-                </a:r>
-                <a14:m>
-                  <m:oMath xmlns:m="http://schemas.openxmlformats.org/officeDocument/2006/math">
-                    <m:r>
-                      <a:rPr lang="en-US" sz="1200" i="1" dirty="0" smtClean="0">
-                        <a:latin typeface="Cambria Math" panose="02040503050406030204" pitchFamily="18" charset="0"/>
-                      </a:rPr>
-                      <m:t>𝑋</m:t>
-                    </m:r>
-                  </m:oMath>
-                </a14:m>
-                <a:r>
-                  <a:rPr lang="en-US" sz="1200" dirty="0"/>
-                  <a:t>, i.e.,</a:t>
-                </a:r>
-                <a14:m>
-                  <m:oMath xmlns:m="http://schemas.openxmlformats.org/officeDocument/2006/math">
-                    <m:r>
-                      <a:rPr lang="en-US" sz="1200" i="1">
-                        <a:latin typeface="Cambria Math" panose="02040503050406030204" pitchFamily="18" charset="0"/>
-                        <a:ea typeface="Cambria Math" panose="02040503050406030204" pitchFamily="18" charset="0"/>
-                      </a:rPr>
-                      <m:t>𝔼</m:t>
-                    </m:r>
-                    <m:d>
-                      <m:dPr>
-                        <m:begChr m:val="["/>
-                        <m:endChr m:val="]"/>
-                        <m:ctrlPr>
-                          <a:rPr lang="en-US" sz="1200" i="1">
-                            <a:latin typeface="Cambria Math" panose="02040503050406030204" pitchFamily="18" charset="0"/>
-                            <a:ea typeface="Cambria Math" panose="02040503050406030204" pitchFamily="18" charset="0"/>
-                          </a:rPr>
-                        </m:ctrlPr>
-                      </m:dPr>
-                      <m:e>
-                        <m:r>
-                          <a:rPr lang="en-US" sz="1200" i="1">
-                            <a:latin typeface="Cambria Math" panose="02040503050406030204" pitchFamily="18" charset="0"/>
-                            <a:ea typeface="Cambria Math" panose="02040503050406030204" pitchFamily="18" charset="0"/>
-                          </a:rPr>
-                          <m:t>𝑋</m:t>
-                        </m:r>
-                      </m:e>
-                    </m:d>
-                    <m:r>
-                      <a:rPr lang="en-US" sz="1200" b="0" i="1" smtClean="0">
-                        <a:latin typeface="Cambria Math" panose="02040503050406030204" pitchFamily="18" charset="0"/>
-                        <a:ea typeface="Cambria Math" panose="02040503050406030204" pitchFamily="18" charset="0"/>
-                      </a:rPr>
-                      <m:t>=</m:t>
-                    </m:r>
-                    <m:nary>
-                      <m:naryPr>
-                        <m:chr m:val="∑"/>
-                        <m:supHide m:val="on"/>
-                        <m:ctrlPr>
-                          <a:rPr lang="en-US" sz="1200" b="0" i="1" smtClean="0">
-                            <a:latin typeface="Cambria Math" panose="02040503050406030204" pitchFamily="18" charset="0"/>
-                            <a:ea typeface="Cambria Math" panose="02040503050406030204" pitchFamily="18" charset="0"/>
-                          </a:rPr>
-                        </m:ctrlPr>
-                      </m:naryPr>
-                      <m:sub>
-                        <m:r>
-                          <a:rPr lang="en-US" sz="1200" b="0" i="1" smtClean="0">
-                            <a:latin typeface="Cambria Math" panose="02040503050406030204" pitchFamily="18" charset="0"/>
-                            <a:ea typeface="Cambria Math" panose="02040503050406030204" pitchFamily="18" charset="0"/>
-                          </a:rPr>
-                          <m:t>𝑥</m:t>
-                        </m:r>
-                      </m:sub>
-                      <m:sup/>
-                      <m:e>
-                        <m:r>
-                          <a:rPr lang="en-US" sz="1200" b="0" i="1" smtClean="0">
-                            <a:latin typeface="Cambria Math" panose="02040503050406030204" pitchFamily="18" charset="0"/>
-                            <a:ea typeface="Cambria Math" panose="02040503050406030204" pitchFamily="18" charset="0"/>
-                          </a:rPr>
-                          <m:t>𝑝</m:t>
-                        </m:r>
-                        <m:d>
-                          <m:dPr>
-                            <m:ctrlPr>
-                              <a:rPr lang="en-US" sz="1200" b="0" i="1" smtClean="0">
-                                <a:latin typeface="Cambria Math" panose="02040503050406030204" pitchFamily="18" charset="0"/>
-                                <a:ea typeface="Cambria Math" panose="02040503050406030204" pitchFamily="18" charset="0"/>
-                              </a:rPr>
-                            </m:ctrlPr>
-                          </m:dPr>
-                          <m:e>
-                            <m:r>
-                              <a:rPr lang="en-US" sz="1200" b="0" i="1" smtClean="0">
-                                <a:latin typeface="Cambria Math" panose="02040503050406030204" pitchFamily="18" charset="0"/>
-                                <a:ea typeface="Cambria Math" panose="02040503050406030204" pitchFamily="18" charset="0"/>
-                              </a:rPr>
-                              <m:t>𝑥</m:t>
-                            </m:r>
-                          </m:e>
-                        </m:d>
-                        <m:r>
-                          <a:rPr lang="en-US" sz="1200" b="0" i="1" smtClean="0">
-                            <a:latin typeface="Cambria Math" panose="02040503050406030204" pitchFamily="18" charset="0"/>
-                            <a:ea typeface="Cambria Math" panose="02040503050406030204" pitchFamily="18" charset="0"/>
-                          </a:rPr>
-                          <m:t>𝑥</m:t>
-                        </m:r>
-                      </m:e>
-                    </m:nary>
-                  </m:oMath>
-                </a14:m>
-                <a:endParaRPr lang="en-US" sz="1200" b="0" dirty="0">
-                  <a:ea typeface="Cambria Math" panose="02040503050406030204" pitchFamily="18" charset="0"/>
+                  <a:t> 	discount-rate parameter</a:t>
+                </a:r>
+                <a:endParaRPr lang="en-US" sz="1200" i="1" dirty="0">
+                  <a:latin typeface="Cambria Math" panose="02040503050406030204" pitchFamily="18" charset="0"/>
                 </a:endParaRPr>
-              </a:p>
-              <a:p>
-                <a:pPr marL="0" indent="0">
-                  <a:spcBef>
-                    <a:spcPts val="0"/>
-                  </a:spcBef>
-                  <a:buNone/>
-                </a:pPr>
-                <a14:m>
-                  <m:oMath xmlns:m="http://schemas.openxmlformats.org/officeDocument/2006/math">
-                    <m:sSub>
-                      <m:sSubPr>
-                        <m:ctrlPr>
-                          <a:rPr lang="en-US" sz="1200" b="0" i="1" dirty="0" smtClean="0">
-                            <a:latin typeface="Cambria Math" panose="02040503050406030204" pitchFamily="18" charset="0"/>
-                          </a:rPr>
-                        </m:ctrlPr>
-                      </m:sSubPr>
-                      <m:e>
-                        <m:r>
-                          <m:rPr>
-                            <m:sty m:val="p"/>
-                          </m:rPr>
-                          <a:rPr lang="en-US" sz="1200" b="0" i="0" dirty="0" smtClean="0">
-                            <a:latin typeface="Cambria Math" panose="02040503050406030204" pitchFamily="18" charset="0"/>
-                          </a:rPr>
-                          <m:t>argmax</m:t>
-                        </m:r>
-                      </m:e>
-                      <m:sub>
-                        <m:r>
-                          <m:rPr>
-                            <m:sty m:val="p"/>
-                          </m:rPr>
-                          <a:rPr lang="en-US" sz="1200" b="0" i="0" dirty="0" smtClean="0">
-                            <a:latin typeface="Cambria Math" panose="02040503050406030204" pitchFamily="18" charset="0"/>
-                          </a:rPr>
-                          <m:t>a</m:t>
-                        </m:r>
-                      </m:sub>
-                    </m:sSub>
-                    <m:r>
-                      <a:rPr lang="en-US" sz="1200" b="0" i="0" dirty="0" smtClean="0">
-                        <a:latin typeface="Cambria Math" panose="02040503050406030204" pitchFamily="18" charset="0"/>
-                      </a:rPr>
-                      <m:t> </m:t>
-                    </m:r>
-                    <m:r>
-                      <a:rPr lang="en-US" sz="1200" i="1" dirty="0">
-                        <a:latin typeface="Cambria Math" panose="02040503050406030204" pitchFamily="18" charset="0"/>
-                      </a:rPr>
-                      <m:t>𝑓</m:t>
-                    </m:r>
-                    <m:r>
-                      <a:rPr lang="en-US" sz="1200" i="1" dirty="0">
-                        <a:latin typeface="Cambria Math" panose="02040503050406030204" pitchFamily="18" charset="0"/>
-                      </a:rPr>
-                      <m:t>(</m:t>
-                    </m:r>
-                    <m:r>
-                      <a:rPr lang="en-US" sz="1200" i="1" dirty="0">
-                        <a:latin typeface="Cambria Math" panose="02040503050406030204" pitchFamily="18" charset="0"/>
-                      </a:rPr>
-                      <m:t>𝑎</m:t>
-                    </m:r>
-                    <m:r>
-                      <a:rPr lang="en-US" sz="1200" i="1" dirty="0">
-                        <a:latin typeface="Cambria Math" panose="02040503050406030204" pitchFamily="18" charset="0"/>
-                      </a:rPr>
-                      <m:t>)</m:t>
-                    </m:r>
-                  </m:oMath>
-                </a14:m>
-                <a:r>
-                  <a:rPr lang="en-US" sz="1200" dirty="0"/>
-                  <a:t> a value of action </a:t>
-                </a:r>
-                <a14:m>
-                  <m:oMath xmlns:m="http://schemas.openxmlformats.org/officeDocument/2006/math">
-                    <m:r>
-                      <a:rPr lang="en-US" sz="1200" i="1" dirty="0" smtClean="0">
-                        <a:latin typeface="Cambria Math" panose="02040503050406030204" pitchFamily="18" charset="0"/>
-                      </a:rPr>
-                      <m:t>𝑎</m:t>
-                    </m:r>
-                  </m:oMath>
-                </a14:m>
-                <a:r>
-                  <a:rPr lang="en-US" sz="1200" dirty="0"/>
-                  <a:t> at which </a:t>
-                </a:r>
-                <a14:m>
-                  <m:oMath xmlns:m="http://schemas.openxmlformats.org/officeDocument/2006/math">
-                    <m:r>
-                      <a:rPr lang="en-US" sz="1200" i="1" dirty="0" smtClean="0">
-                        <a:latin typeface="Cambria Math" panose="02040503050406030204" pitchFamily="18" charset="0"/>
-                      </a:rPr>
-                      <m:t>𝑓</m:t>
-                    </m:r>
-                    <m:r>
-                      <a:rPr lang="en-US" sz="1200" i="1" dirty="0" smtClean="0">
-                        <a:latin typeface="Cambria Math" panose="02040503050406030204" pitchFamily="18" charset="0"/>
-                      </a:rPr>
-                      <m:t>(</m:t>
-                    </m:r>
-                    <m:r>
-                      <a:rPr lang="en-US" sz="1200" i="1" dirty="0" smtClean="0">
-                        <a:latin typeface="Cambria Math" panose="02040503050406030204" pitchFamily="18" charset="0"/>
-                      </a:rPr>
-                      <m:t>𝑎</m:t>
-                    </m:r>
-                    <m:r>
-                      <a:rPr lang="en-US" sz="1200" i="1" dirty="0" smtClean="0">
-                        <a:latin typeface="Cambria Math" panose="02040503050406030204" pitchFamily="18" charset="0"/>
-                      </a:rPr>
-                      <m:t>)</m:t>
-                    </m:r>
-                  </m:oMath>
-                </a14:m>
-                <a:r>
-                  <a:rPr lang="en-US" sz="1200" dirty="0"/>
-                  <a:t> takes its maximal value</a:t>
-                </a:r>
-              </a:p>
-              <a:p>
-                <a:pPr marL="0" indent="0">
-                  <a:spcBef>
-                    <a:spcPts val="0"/>
-                  </a:spcBef>
-                  <a:buNone/>
-                </a:pPr>
-                <a14:m>
-                  <m:oMath xmlns:m="http://schemas.openxmlformats.org/officeDocument/2006/math">
-                    <m:r>
-                      <a:rPr lang="en-US" sz="1200" b="0" i="1" smtClean="0">
-                        <a:latin typeface="Cambria Math" panose="02040503050406030204" pitchFamily="18" charset="0"/>
-                      </a:rPr>
-                      <m:t>𝛾</m:t>
-                    </m:r>
-                  </m:oMath>
-                </a14:m>
-                <a:r>
-                  <a:rPr lang="en-US" sz="1200" dirty="0"/>
-                  <a:t> 	discount-rate parameter</a:t>
-                </a:r>
-              </a:p>
-            </p:txBody>
-          </p:sp>
-        </mc:Choice>
-        <mc:Fallback xmlns="">
-          <p:sp>
-            <p:nvSpPr>
-              <p:cNvPr id="6" name="Content Placeholder 2">
-                <a:extLst>
-                  <a:ext uri="{FF2B5EF4-FFF2-40B4-BE49-F238E27FC236}">
-                    <a16:creationId xmlns:a16="http://schemas.microsoft.com/office/drawing/2014/main" id="{708B36CA-535B-718D-F6EB-D4F59B9D2614}"/>
-                  </a:ext>
-                </a:extLst>
-              </p:cNvPr>
-              <p:cNvSpPr txBox="1">
-                <a:spLocks noRot="1" noChangeAspect="1" noMove="1" noResize="1" noEditPoints="1" noAdjustHandles="1" noChangeArrowheads="1" noChangeShapeType="1" noTextEdit="1"/>
-              </p:cNvSpPr>
-              <p:nvPr/>
-            </p:nvSpPr>
-            <p:spPr>
-              <a:xfrm>
-                <a:off x="822821" y="2150317"/>
-                <a:ext cx="5273179" cy="958576"/>
-              </a:xfrm>
-              <a:prstGeom prst="rect">
-                <a:avLst/>
-              </a:prstGeom>
-              <a:blipFill>
-                <a:blip r:embed="rId3"/>
-                <a:stretch>
-                  <a:fillRect t="-1875" b="-5625"/>
-                </a:stretch>
-              </a:blipFill>
-            </p:spPr>
-            <p:txBody>
-              <a:bodyPr/>
-              <a:lstStyle/>
-              <a:p>
-                <a:r>
-                  <a:rPr lang="en-US">
-                    <a:noFill/>
-                  </a:rPr>
-                  <a:t> </a:t>
-                </a:r>
-              </a:p>
-            </p:txBody>
-          </p:sp>
-        </mc:Fallback>
-      </mc:AlternateContent>
-      <p:sp>
-        <p:nvSpPr>
-          <p:cNvPr id="10" name="TextBox 9">
-            <a:extLst>
-              <a:ext uri="{FF2B5EF4-FFF2-40B4-BE49-F238E27FC236}">
-                <a16:creationId xmlns:a16="http://schemas.microsoft.com/office/drawing/2014/main" id="{5CD475E5-BE3B-5594-57DC-46A17411F2F9}"/>
-              </a:ext>
-            </a:extLst>
-          </p:cNvPr>
-          <p:cNvSpPr txBox="1"/>
-          <p:nvPr/>
-        </p:nvSpPr>
-        <p:spPr>
-          <a:xfrm>
-            <a:off x="822820" y="1124198"/>
-            <a:ext cx="5273179" cy="830997"/>
-          </a:xfrm>
-          <a:prstGeom prst="rect">
-            <a:avLst/>
-          </a:prstGeom>
-        </p:spPr>
-        <p:style>
-          <a:lnRef idx="2">
-            <a:schemeClr val="accent2"/>
-          </a:lnRef>
-          <a:fillRef idx="1">
-            <a:schemeClr val="lt1"/>
-          </a:fillRef>
-          <a:effectRef idx="0">
-            <a:schemeClr val="accent2"/>
-          </a:effectRef>
-          <a:fontRef idx="minor">
-            <a:schemeClr val="dk1"/>
-          </a:fontRef>
-        </p:style>
-        <p:txBody>
-          <a:bodyPr wrap="square">
-            <a:spAutoFit/>
-          </a:bodyPr>
-          <a:lstStyle/>
-          <a:p>
-            <a:r>
-              <a:rPr lang="en-US" sz="1200" dirty="0"/>
-              <a:t>Capital letters          random variables</a:t>
-            </a:r>
-            <a:br>
-              <a:rPr lang="en-US" sz="1200" dirty="0"/>
-            </a:br>
-            <a:r>
-              <a:rPr lang="en-US" sz="1200" dirty="0"/>
-              <a:t>Lower case letters realizations of random variables and for scalar functions</a:t>
-            </a:r>
-          </a:p>
-          <a:p>
-            <a:r>
-              <a:rPr lang="en-US" sz="1200" dirty="0"/>
-              <a:t>Bold lower case letters real-valued vectors (even if random variables)</a:t>
-            </a:r>
-          </a:p>
-          <a:p>
-            <a:r>
-              <a:rPr lang="en-US" sz="1200" dirty="0"/>
-              <a:t>Bold capitals            matrices</a:t>
-            </a:r>
-          </a:p>
-        </p:txBody>
-      </p:sp>
-      <mc:AlternateContent xmlns:mc="http://schemas.openxmlformats.org/markup-compatibility/2006" xmlns:a14="http://schemas.microsoft.com/office/drawing/2010/main">
-        <mc:Choice Requires="a14">
-          <p:sp>
-            <p:nvSpPr>
-              <p:cNvPr id="11" name="Content Placeholder 2">
-                <a:extLst>
-                  <a:ext uri="{FF2B5EF4-FFF2-40B4-BE49-F238E27FC236}">
-                    <a16:creationId xmlns:a16="http://schemas.microsoft.com/office/drawing/2014/main" id="{6F45EA4F-65F9-5141-0B09-C395CF9CA7A0}"/>
-                  </a:ext>
-                </a:extLst>
-              </p:cNvPr>
-              <p:cNvSpPr txBox="1">
-                <a:spLocks/>
-              </p:cNvSpPr>
-              <p:nvPr/>
-            </p:nvSpPr>
-            <p:spPr>
-              <a:xfrm>
-                <a:off x="822819" y="3291317"/>
-                <a:ext cx="5273179" cy="2309203"/>
-              </a:xfrm>
-              <a:prstGeom prst="rect">
-                <a:avLst/>
-              </a:prstGeom>
-            </p:spPr>
-            <p:style>
-              <a:lnRef idx="2">
-                <a:schemeClr val="accent2"/>
-              </a:lnRef>
-              <a:fillRef idx="1">
-                <a:schemeClr val="lt1"/>
-              </a:fillRef>
-              <a:effectRef idx="0">
-                <a:schemeClr val="accent2"/>
-              </a:effectRef>
-              <a:fontRef idx="minor">
-                <a:schemeClr val="dk1"/>
-              </a:fontRef>
-            </p:style>
-            <p:txBody>
-              <a:bodyPr vert="horz" lIns="91440" tIns="45720" rIns="91440" bIns="45720" rtlCol="0">
-                <a:noAutofit/>
-              </a:bodyPr>
-              <a:lstStyle>
-                <a:lvl1pPr marL="228600" indent="-228600" algn="l" defTabSz="914400" rtl="0" eaLnBrk="1" latinLnBrk="0" hangingPunct="1">
-                  <a:lnSpc>
-                    <a:spcPct val="90000"/>
-                  </a:lnSpc>
-                  <a:spcBef>
-                    <a:spcPts val="1000"/>
-                  </a:spcBef>
-                  <a:buFont typeface="Arial" panose="020B0604020202020204" pitchFamily="34" charset="0"/>
-                  <a:buChar char="•"/>
-                  <a:defRPr sz="2800" kern="1200">
-                    <a:solidFill>
-                      <a:schemeClr val="tx1"/>
-                    </a:solidFill>
-                    <a:latin typeface="+mn-lt"/>
-                    <a:ea typeface="+mn-ea"/>
-                    <a:cs typeface="+mn-cs"/>
-                  </a:defRPr>
-                </a:lvl1pPr>
-                <a:lvl2pPr marL="685800" indent="-228600" algn="l" defTabSz="914400" rtl="0" eaLnBrk="1" latinLnBrk="0" hangingPunct="1">
-                  <a:lnSpc>
-                    <a:spcPct val="90000"/>
-                  </a:lnSpc>
-                  <a:spcBef>
-                    <a:spcPts val="500"/>
-                  </a:spcBef>
-                  <a:buFont typeface="Arial" panose="020B0604020202020204" pitchFamily="34" charset="0"/>
-                  <a:buChar char="•"/>
-                  <a:defRPr sz="2400" kern="1200">
-                    <a:solidFill>
-                      <a:schemeClr val="tx1"/>
-                    </a:solidFill>
-                    <a:latin typeface="+mn-lt"/>
-                    <a:ea typeface="+mn-ea"/>
-                    <a:cs typeface="+mn-cs"/>
-                  </a:defRPr>
-                </a:lvl2pPr>
-                <a:lvl3pPr marL="1143000" indent="-228600" algn="l" defTabSz="914400" rtl="0" eaLnBrk="1" latinLnBrk="0" hangingPunct="1">
-                  <a:lnSpc>
-                    <a:spcPct val="90000"/>
-                  </a:lnSpc>
-                  <a:spcBef>
-                    <a:spcPts val="500"/>
-                  </a:spcBef>
-                  <a:buFont typeface="Arial" panose="020B0604020202020204" pitchFamily="34" charset="0"/>
-                  <a:buChar char="•"/>
-                  <a:defRPr sz="2000" kern="1200">
-                    <a:solidFill>
-                      <a:schemeClr val="tx1"/>
-                    </a:solidFill>
-                    <a:latin typeface="+mn-lt"/>
-                    <a:ea typeface="+mn-ea"/>
-                    <a:cs typeface="+mn-cs"/>
-                  </a:defRPr>
-                </a:lvl3pPr>
-                <a:lvl4pPr marL="1600200" indent="-228600" algn="l" defTabSz="914400" rtl="0" eaLnBrk="1" latinLnBrk="0" hangingPunct="1">
-                  <a:lnSpc>
-                    <a:spcPct val="90000"/>
-                  </a:lnSpc>
-                  <a:spcBef>
-                    <a:spcPts val="500"/>
-                  </a:spcBef>
-                  <a:buFont typeface="Arial" panose="020B0604020202020204" pitchFamily="34" charset="0"/>
-                  <a:buChar char="•"/>
-                  <a:defRPr sz="1800" kern="1200">
-                    <a:solidFill>
-                      <a:schemeClr val="tx1"/>
-                    </a:solidFill>
-                    <a:latin typeface="+mn-lt"/>
-                    <a:ea typeface="+mn-ea"/>
-                    <a:cs typeface="+mn-cs"/>
-                  </a:defRPr>
-                </a:lvl4pPr>
-                <a:lvl5pPr marL="2057400" indent="-228600" algn="l" defTabSz="914400" rtl="0" eaLnBrk="1" latinLnBrk="0" hangingPunct="1">
-                  <a:lnSpc>
-                    <a:spcPct val="90000"/>
-                  </a:lnSpc>
-                  <a:spcBef>
-                    <a:spcPts val="500"/>
-                  </a:spcBef>
-                  <a:buFont typeface="Arial" panose="020B0604020202020204" pitchFamily="34" charset="0"/>
-                  <a:buChar char="•"/>
-                  <a:defRPr sz="1800" kern="1200">
-                    <a:solidFill>
-                      <a:schemeClr val="tx1"/>
-                    </a:solidFill>
-                    <a:latin typeface="+mn-lt"/>
-                    <a:ea typeface="+mn-ea"/>
-                    <a:cs typeface="+mn-cs"/>
-                  </a:defRPr>
-                </a:lvl5pPr>
-                <a:lvl6pPr marL="2514600" indent="-228600" algn="l" defTabSz="914400" rtl="0" eaLnBrk="1" latinLnBrk="0" hangingPunct="1">
-                  <a:lnSpc>
-                    <a:spcPct val="90000"/>
-                  </a:lnSpc>
-                  <a:spcBef>
-                    <a:spcPts val="500"/>
-                  </a:spcBef>
-                  <a:buFont typeface="Arial" panose="020B0604020202020204" pitchFamily="34" charset="0"/>
-                  <a:buChar char="•"/>
-                  <a:defRPr sz="1800" kern="1200">
-                    <a:solidFill>
-                      <a:schemeClr val="tx1"/>
-                    </a:solidFill>
-                    <a:latin typeface="+mn-lt"/>
-                    <a:ea typeface="+mn-ea"/>
-                    <a:cs typeface="+mn-cs"/>
-                  </a:defRPr>
-                </a:lvl6pPr>
-                <a:lvl7pPr marL="2971800" indent="-228600" algn="l" defTabSz="914400" rtl="0" eaLnBrk="1" latinLnBrk="0" hangingPunct="1">
-                  <a:lnSpc>
-                    <a:spcPct val="90000"/>
-                  </a:lnSpc>
-                  <a:spcBef>
-                    <a:spcPts val="500"/>
-                  </a:spcBef>
-                  <a:buFont typeface="Arial" panose="020B0604020202020204" pitchFamily="34" charset="0"/>
-                  <a:buChar char="•"/>
-                  <a:defRPr sz="1800" kern="1200">
-                    <a:solidFill>
-                      <a:schemeClr val="tx1"/>
-                    </a:solidFill>
-                    <a:latin typeface="+mn-lt"/>
-                    <a:ea typeface="+mn-ea"/>
-                    <a:cs typeface="+mn-cs"/>
-                  </a:defRPr>
-                </a:lvl7pPr>
-                <a:lvl8pPr marL="3429000" indent="-228600" algn="l" defTabSz="914400" rtl="0" eaLnBrk="1" latinLnBrk="0" hangingPunct="1">
-                  <a:lnSpc>
-                    <a:spcPct val="90000"/>
-                  </a:lnSpc>
-                  <a:spcBef>
-                    <a:spcPts val="500"/>
-                  </a:spcBef>
-                  <a:buFont typeface="Arial" panose="020B0604020202020204" pitchFamily="34" charset="0"/>
-                  <a:buChar char="•"/>
-                  <a:defRPr sz="1800" kern="1200">
-                    <a:solidFill>
-                      <a:schemeClr val="tx1"/>
-                    </a:solidFill>
-                    <a:latin typeface="+mn-lt"/>
-                    <a:ea typeface="+mn-ea"/>
-                    <a:cs typeface="+mn-cs"/>
-                  </a:defRPr>
-                </a:lvl8pPr>
-                <a:lvl9pPr marL="3886200" indent="-228600" algn="l" defTabSz="914400" rtl="0" eaLnBrk="1" latinLnBrk="0" hangingPunct="1">
-                  <a:lnSpc>
-                    <a:spcPct val="90000"/>
-                  </a:lnSpc>
-                  <a:spcBef>
-                    <a:spcPts val="500"/>
-                  </a:spcBef>
-                  <a:buFont typeface="Arial" panose="020B0604020202020204" pitchFamily="34" charset="0"/>
-                  <a:buChar char="•"/>
-                  <a:defRPr sz="1800" kern="1200">
-                    <a:solidFill>
-                      <a:schemeClr val="tx1"/>
-                    </a:solidFill>
-                    <a:latin typeface="+mn-lt"/>
-                    <a:ea typeface="+mn-ea"/>
-                    <a:cs typeface="+mn-cs"/>
-                  </a:defRPr>
-                </a:lvl9pPr>
-              </a:lstStyle>
-              <a:p>
-                <a:pPr marL="0" indent="0">
-                  <a:spcBef>
-                    <a:spcPts val="0"/>
-                  </a:spcBef>
-                  <a:buNone/>
-                </a:pPr>
-                <a14:m>
-                  <m:oMath xmlns:m="http://schemas.openxmlformats.org/officeDocument/2006/math">
-                    <m:r>
-                      <a:rPr lang="en-US" sz="1200" i="1" dirty="0" smtClean="0">
-                        <a:latin typeface="Cambria Math" panose="02040503050406030204" pitchFamily="18" charset="0"/>
-                      </a:rPr>
-                      <m:t>𝑠</m:t>
-                    </m:r>
-                    <m:r>
-                      <a:rPr lang="en-US" sz="1200" i="1" dirty="0" smtClean="0">
-                        <a:latin typeface="Cambria Math" panose="02040503050406030204" pitchFamily="18" charset="0"/>
-                      </a:rPr>
-                      <m:t>, </m:t>
-                    </m:r>
-                    <m:r>
-                      <a:rPr lang="en-US" sz="1200" i="1" dirty="0" smtClean="0">
-                        <a:latin typeface="Cambria Math" panose="02040503050406030204" pitchFamily="18" charset="0"/>
-                      </a:rPr>
-                      <m:t>𝑠</m:t>
-                    </m:r>
-                    <m:r>
-                      <a:rPr lang="en-US" sz="1200" b="0" i="1" dirty="0" smtClean="0">
-                        <a:latin typeface="Cambria Math" panose="02040503050406030204" pitchFamily="18" charset="0"/>
-                      </a:rPr>
-                      <m:t>′</m:t>
-                    </m:r>
-                  </m:oMath>
-                </a14:m>
-                <a:r>
-                  <a:rPr lang="en-US" sz="1200" dirty="0"/>
-                  <a:t> 	states</a:t>
-                </a:r>
-              </a:p>
-              <a:p>
-                <a:pPr marL="0" indent="0">
-                  <a:spcBef>
-                    <a:spcPts val="0"/>
-                  </a:spcBef>
-                  <a:buNone/>
-                </a:pPr>
-                <a14:m>
-                  <m:oMath xmlns:m="http://schemas.openxmlformats.org/officeDocument/2006/math">
-                    <m:r>
-                      <a:rPr lang="en-US" sz="1200" i="1" dirty="0" smtClean="0">
-                        <a:latin typeface="Cambria Math" panose="02040503050406030204" pitchFamily="18" charset="0"/>
-                      </a:rPr>
-                      <m:t>𝑎</m:t>
-                    </m:r>
-                  </m:oMath>
-                </a14:m>
-                <a:r>
-                  <a:rPr lang="en-US" sz="1200" dirty="0"/>
-                  <a:t> 	an action</a:t>
-                </a:r>
-              </a:p>
-              <a:p>
-                <a:pPr marL="0" indent="0">
-                  <a:spcBef>
-                    <a:spcPts val="0"/>
-                  </a:spcBef>
-                  <a:buNone/>
-                </a:pPr>
-                <a14:m>
-                  <m:oMath xmlns:m="http://schemas.openxmlformats.org/officeDocument/2006/math">
-                    <m:r>
-                      <a:rPr lang="en-US" sz="1200" i="1" dirty="0" smtClean="0">
-                        <a:latin typeface="Cambria Math" panose="02040503050406030204" pitchFamily="18" charset="0"/>
-                      </a:rPr>
-                      <m:t>𝑟</m:t>
-                    </m:r>
-                  </m:oMath>
-                </a14:m>
-                <a:r>
-                  <a:rPr lang="en-US" sz="1200" dirty="0"/>
-                  <a:t> 	a reward</a:t>
-                </a:r>
-              </a:p>
-              <a:p>
-                <a:pPr marL="0" indent="0">
-                  <a:spcBef>
-                    <a:spcPts val="0"/>
-                  </a:spcBef>
-                  <a:buNone/>
-                </a:pPr>
-                <a14:m>
-                  <m:oMath xmlns:m="http://schemas.openxmlformats.org/officeDocument/2006/math">
-                    <m:r>
-                      <a:rPr lang="en-US" sz="1200" i="1" dirty="0" smtClean="0">
-                        <a:latin typeface="Cambria Math" panose="02040503050406030204" pitchFamily="18" charset="0"/>
-                        <a:ea typeface="Cambria Math" panose="02040503050406030204" pitchFamily="18" charset="0"/>
-                      </a:rPr>
-                      <m:t>𝒮</m:t>
-                    </m:r>
-                  </m:oMath>
-                </a14:m>
-                <a:r>
-                  <a:rPr lang="en-US" sz="1200" dirty="0"/>
-                  <a:t> 	set of all (nonterminal) states</a:t>
-                </a:r>
-              </a:p>
-              <a:p>
-                <a:pPr marL="0" indent="0">
-                  <a:spcBef>
-                    <a:spcPts val="0"/>
-                  </a:spcBef>
-                  <a:buNone/>
-                </a:pPr>
-                <a14:m>
-                  <m:oMath xmlns:m="http://schemas.openxmlformats.org/officeDocument/2006/math">
-                    <m:r>
-                      <a:rPr lang="en-US" sz="1200" i="1" dirty="0" smtClean="0">
-                        <a:latin typeface="Cambria Math" panose="02040503050406030204" pitchFamily="18" charset="0"/>
-                        <a:ea typeface="Cambria Math" panose="02040503050406030204" pitchFamily="18" charset="0"/>
-                      </a:rPr>
-                      <m:t>𝒜</m:t>
-                    </m:r>
-                    <m:r>
-                      <a:rPr lang="en-US" sz="1200" i="1" dirty="0">
-                        <a:latin typeface="Cambria Math" panose="02040503050406030204" pitchFamily="18" charset="0"/>
-                      </a:rPr>
-                      <m:t>(</m:t>
-                    </m:r>
-                    <m:r>
-                      <a:rPr lang="en-US" sz="1200" i="1" dirty="0">
-                        <a:latin typeface="Cambria Math" panose="02040503050406030204" pitchFamily="18" charset="0"/>
-                      </a:rPr>
-                      <m:t>𝑠</m:t>
-                    </m:r>
-                    <m:r>
-                      <a:rPr lang="en-US" sz="1200" i="1" dirty="0">
-                        <a:latin typeface="Cambria Math" panose="02040503050406030204" pitchFamily="18" charset="0"/>
-                      </a:rPr>
-                      <m:t>)</m:t>
-                    </m:r>
-                  </m:oMath>
-                </a14:m>
-                <a:r>
-                  <a:rPr lang="en-US" sz="1200" dirty="0"/>
-                  <a:t>	set of all actions available in state </a:t>
-                </a:r>
-                <a14:m>
-                  <m:oMath xmlns:m="http://schemas.openxmlformats.org/officeDocument/2006/math">
-                    <m:r>
-                      <a:rPr lang="en-US" sz="1200" i="1" dirty="0" smtClean="0">
-                        <a:latin typeface="Cambria Math" panose="02040503050406030204" pitchFamily="18" charset="0"/>
-                      </a:rPr>
-                      <m:t>𝑠</m:t>
-                    </m:r>
-                  </m:oMath>
-                </a14:m>
-                <a:endParaRPr lang="en-US" sz="1200" dirty="0"/>
               </a:p>
               <a:p>
                 <a:pPr marL="0" indent="0">
@@ -14904,6 +15340,9 @@
               </a:p>
               <a:p>
                 <a:pPr marL="0" indent="0">
+                  <a:lnSpc>
+                    <a:spcPct val="100000"/>
+                  </a:lnSpc>
                   <a:spcBef>
                     <a:spcPts val="0"/>
                   </a:spcBef>
@@ -14912,17 +15351,204 @@
                 <a14:m>
                   <m:oMath xmlns:m="http://schemas.openxmlformats.org/officeDocument/2006/math">
                     <m:r>
-                      <a:rPr lang="en-US" sz="1200" b="0" i="1" dirty="0" smtClean="0">
-                        <a:latin typeface="Cambria Math" panose="02040503050406030204" pitchFamily="18" charset="0"/>
-                      </a:rPr>
-                      <m:t>𝜋</m:t>
+                      <a:rPr lang="en-US" sz="1200" i="1" dirty="0">
+                        <a:latin typeface="Cambria Math" panose="02040503050406030204" pitchFamily="18" charset="0"/>
+                      </a:rPr>
+                      <m:t>𝑝</m:t>
+                    </m:r>
+                    <m:d>
+                      <m:dPr>
+                        <m:endChr m:val="|"/>
+                        <m:ctrlPr>
+                          <a:rPr lang="en-US" sz="1200" i="1" dirty="0">
+                            <a:latin typeface="Cambria Math" panose="02040503050406030204" pitchFamily="18" charset="0"/>
+                          </a:rPr>
+                        </m:ctrlPr>
+                      </m:dPr>
+                      <m:e>
+                        <m:sSup>
+                          <m:sSupPr>
+                            <m:ctrlPr>
+                              <a:rPr lang="en-US" sz="1200" i="1" dirty="0">
+                                <a:latin typeface="Cambria Math" panose="02040503050406030204" pitchFamily="18" charset="0"/>
+                              </a:rPr>
+                            </m:ctrlPr>
+                          </m:sSupPr>
+                          <m:e>
+                            <m:r>
+                              <a:rPr lang="en-US" sz="1200" i="1" dirty="0">
+                                <a:latin typeface="Cambria Math" panose="02040503050406030204" pitchFamily="18" charset="0"/>
+                              </a:rPr>
+                              <m:t>𝑠</m:t>
+                            </m:r>
+                          </m:e>
+                          <m:sup>
+                            <m:r>
+                              <a:rPr lang="en-US" sz="1200" i="1" dirty="0">
+                                <a:latin typeface="Cambria Math" panose="02040503050406030204" pitchFamily="18" charset="0"/>
+                              </a:rPr>
+                              <m:t>′</m:t>
+                            </m:r>
+                          </m:sup>
+                        </m:sSup>
+                        <m:r>
+                          <a:rPr lang="en-US" sz="1200" b="0" i="1" dirty="0" smtClean="0">
+                            <a:latin typeface="Cambria Math" panose="02040503050406030204" pitchFamily="18" charset="0"/>
+                          </a:rPr>
+                          <m:t>,</m:t>
+                        </m:r>
+                        <m:r>
+                          <a:rPr lang="en-US" sz="1200" b="0" i="1" dirty="0" smtClean="0">
+                            <a:latin typeface="Cambria Math" panose="02040503050406030204" pitchFamily="18" charset="0"/>
+                          </a:rPr>
+                          <m:t>𝑟</m:t>
+                        </m:r>
+                        <m:r>
+                          <a:rPr lang="en-US" sz="1200" i="1" dirty="0">
+                            <a:latin typeface="Cambria Math" panose="02040503050406030204" pitchFamily="18" charset="0"/>
+                          </a:rPr>
+                          <m:t> </m:t>
+                        </m:r>
+                      </m:e>
+                    </m:d>
+                    <m:r>
+                      <a:rPr lang="en-US" sz="1200" i="1" dirty="0">
+                        <a:latin typeface="Cambria Math" panose="02040503050406030204" pitchFamily="18" charset="0"/>
+                      </a:rPr>
+                      <m:t>𝑠</m:t>
+                    </m:r>
+                    <m:r>
+                      <a:rPr lang="en-US" sz="1200" i="1" dirty="0">
+                        <a:latin typeface="Cambria Math" panose="02040503050406030204" pitchFamily="18" charset="0"/>
+                      </a:rPr>
+                      <m:t>, </m:t>
+                    </m:r>
+                    <m:r>
+                      <a:rPr lang="en-US" sz="1200" i="1" dirty="0">
+                        <a:latin typeface="Cambria Math" panose="02040503050406030204" pitchFamily="18" charset="0"/>
+                      </a:rPr>
+                      <m:t>𝑎</m:t>
+                    </m:r>
+                    <m:r>
+                      <a:rPr lang="en-US" sz="1200" i="1" dirty="0">
+                        <a:latin typeface="Cambria Math" panose="02040503050406030204" pitchFamily="18" charset="0"/>
+                      </a:rPr>
+                      <m:t>)</m:t>
                     </m:r>
                   </m:oMath>
                 </a14:m>
                 <a:r>
                   <a:rPr lang="en-US" sz="1200" dirty="0"/>
-                  <a:t> 	policy (decision-making rule)</a:t>
-                </a:r>
+                  <a:t>	probability of transition to state </a:t>
+                </a:r>
+                <a14:m>
+                  <m:oMath xmlns:m="http://schemas.openxmlformats.org/officeDocument/2006/math">
+                    <m:r>
+                      <a:rPr lang="en-US" sz="1200" i="1" dirty="0">
+                        <a:latin typeface="Cambria Math" panose="02040503050406030204" pitchFamily="18" charset="0"/>
+                      </a:rPr>
+                      <m:t>𝑠</m:t>
+                    </m:r>
+                    <m:r>
+                      <a:rPr lang="en-US" sz="1200" i="1" dirty="0">
+                        <a:latin typeface="Cambria Math" panose="02040503050406030204" pitchFamily="18" charset="0"/>
+                      </a:rPr>
+                      <m:t>′</m:t>
+                    </m:r>
+                  </m:oMath>
+                </a14:m>
+                <a:r>
+                  <a:rPr lang="en-US" sz="1200" dirty="0"/>
+                  <a:t> and receiving reward </a:t>
+                </a:r>
+                <a14:m>
+                  <m:oMath xmlns:m="http://schemas.openxmlformats.org/officeDocument/2006/math">
+                    <m:r>
+                      <a:rPr lang="en-US" sz="1200" b="0" i="1" smtClean="0">
+                        <a:latin typeface="Cambria Math" panose="02040503050406030204" pitchFamily="18" charset="0"/>
+                      </a:rPr>
+                      <m:t>𝑟</m:t>
+                    </m:r>
+                  </m:oMath>
+                </a14:m>
+                <a:r>
+                  <a:rPr lang="en-US" sz="1200" dirty="0"/>
+                  <a:t>, </a:t>
+                </a:r>
+                <a:br>
+                  <a:rPr lang="en-US" sz="1200" dirty="0"/>
+                </a:br>
+                <a:r>
+                  <a:rPr lang="en-US" sz="1200" dirty="0"/>
+                  <a:t>	from state </a:t>
+                </a:r>
+                <a14:m>
+                  <m:oMath xmlns:m="http://schemas.openxmlformats.org/officeDocument/2006/math">
+                    <m:r>
+                      <a:rPr lang="en-US" sz="1200" i="1" dirty="0">
+                        <a:latin typeface="Cambria Math" panose="02040503050406030204" pitchFamily="18" charset="0"/>
+                      </a:rPr>
+                      <m:t>𝑠</m:t>
+                    </m:r>
+                  </m:oMath>
+                </a14:m>
+                <a:r>
+                  <a:rPr lang="en-US" sz="1200" dirty="0"/>
+                  <a:t> taking action </a:t>
+                </a:r>
+                <a14:m>
+                  <m:oMath xmlns:m="http://schemas.openxmlformats.org/officeDocument/2006/math">
+                    <m:r>
+                      <a:rPr lang="en-US" sz="1200" i="1" dirty="0">
+                        <a:latin typeface="Cambria Math" panose="02040503050406030204" pitchFamily="18" charset="0"/>
+                      </a:rPr>
+                      <m:t>𝑎</m:t>
+                    </m:r>
+                  </m:oMath>
+                </a14:m>
+                <a:endParaRPr lang="en-US" sz="1200" dirty="0"/>
+              </a:p>
+              <a:p>
+                <a:pPr marL="0" indent="0">
+                  <a:lnSpc>
+                    <a:spcPct val="100000"/>
+                  </a:lnSpc>
+                  <a:spcBef>
+                    <a:spcPts val="0"/>
+                  </a:spcBef>
+                  <a:buNone/>
+                </a:pPr>
+                <a:r>
+                  <a:rPr lang="en-US" sz="1200" dirty="0"/>
+                  <a:t>	expected immediate reward from state </a:t>
+                </a:r>
+                <a14:m>
+                  <m:oMath xmlns:m="http://schemas.openxmlformats.org/officeDocument/2006/math">
+                    <m:r>
+                      <a:rPr lang="en-US" sz="1200" i="1" dirty="0">
+                        <a:latin typeface="Cambria Math" panose="02040503050406030204" pitchFamily="18" charset="0"/>
+                      </a:rPr>
+                      <m:t>𝑠</m:t>
+                    </m:r>
+                  </m:oMath>
+                </a14:m>
+                <a:r>
+                  <a:rPr lang="en-US" sz="1200" dirty="0"/>
+                  <a:t> after action </a:t>
+                </a:r>
+                <a14:m>
+                  <m:oMath xmlns:m="http://schemas.openxmlformats.org/officeDocument/2006/math">
+                    <m:r>
+                      <a:rPr lang="en-US" sz="1200" i="1" dirty="0">
+                        <a:latin typeface="Cambria Math" panose="02040503050406030204" pitchFamily="18" charset="0"/>
+                      </a:rPr>
+                      <m:t>𝑎</m:t>
+                    </m:r>
+                  </m:oMath>
+                </a14:m>
+                <a:endParaRPr lang="en-US" sz="1200" i="1" dirty="0">
+                  <a:latin typeface="Cambria Math" panose="02040503050406030204" pitchFamily="18" charset="0"/>
+                </a:endParaRPr>
               </a:p>
               <a:p>
                 <a:pPr marL="0" indent="0">
@@ -14934,25 +15560,37 @@
                 <a14:m>
                   <m:oMath xmlns:m="http://schemas.openxmlformats.org/officeDocument/2006/math">
                     <m:r>
-                      <a:rPr lang="en-US" sz="1200" i="1" dirty="0" smtClean="0">
+                      <a:rPr lang="en-US" sz="1200" i="1" dirty="0">
                         <a:latin typeface="Cambria Math" panose="02040503050406030204" pitchFamily="18" charset="0"/>
                       </a:rPr>
                       <m:t>𝜋</m:t>
                     </m:r>
                     <m:r>
-                      <a:rPr lang="en-US" sz="1200" i="1" dirty="0" smtClean="0">
+                      <a:rPr lang="en-US" sz="1200" i="1" dirty="0">
                         <a:latin typeface="Cambria Math" panose="02040503050406030204" pitchFamily="18" charset="0"/>
                       </a:rPr>
                       <m:t>(</m:t>
                     </m:r>
                     <m:r>
-                      <a:rPr lang="en-US" sz="1200" i="1" dirty="0" smtClean="0">
+                      <a:rPr lang="en-US" sz="1200" i="1" dirty="0" err="1">
+                        <a:latin typeface="Cambria Math" panose="02040503050406030204" pitchFamily="18" charset="0"/>
+                      </a:rPr>
+                      <m:t>𝑎</m:t>
+                    </m:r>
+                    <m:r>
+                      <a:rPr lang="en-US" sz="1200" i="1" dirty="0" err="1">
+                        <a:latin typeface="Cambria Math" panose="02040503050406030204" pitchFamily="18" charset="0"/>
+                      </a:rPr>
+                      <m:t>|</m:t>
+                    </m:r>
+                    <m:r>
+                      <a:rPr lang="en-US" sz="1200" i="1" dirty="0" err="1">
                         <a:latin typeface="Cambria Math" panose="02040503050406030204" pitchFamily="18" charset="0"/>
                       </a:rPr>
                       <m:t>𝑠</m:t>
                     </m:r>
                     <m:r>
-                      <a:rPr lang="en-US" sz="1200" i="1" dirty="0" smtClean="0">
+                      <a:rPr lang="en-US" sz="1200" i="1" dirty="0">
                         <a:latin typeface="Cambria Math" panose="02040503050406030204" pitchFamily="18" charset="0"/>
                       </a:rPr>
                       <m:t>)</m:t>
@@ -14961,33 +15599,49 @@
                 </a14:m>
                 <a:r>
                   <a:rPr lang="en-US" sz="1200" dirty="0"/>
-                  <a:t>	action taken in state </a:t>
+                  <a:t>	probability of taking action </a:t>
                 </a:r>
                 <a14:m>
                   <m:oMath xmlns:m="http://schemas.openxmlformats.org/officeDocument/2006/math">
                     <m:r>
-                      <a:rPr lang="en-US" sz="1200" i="1" dirty="0" smtClean="0">
-                        <a:latin typeface="Cambria Math" panose="02040503050406030204" pitchFamily="18" charset="0"/>
-                      </a:rPr>
-                      <m:t>𝑠</m:t>
+                      <a:rPr lang="en-US" sz="1200" i="1" dirty="0">
+                        <a:latin typeface="Cambria Math" panose="02040503050406030204" pitchFamily="18" charset="0"/>
+                      </a:rPr>
+                      <m:t>𝑎</m:t>
                     </m:r>
                   </m:oMath>
                 </a14:m>
                 <a:r>
                   <a:rPr lang="en-US" sz="1200" dirty="0"/>
-                  <a:t> under deterministic policy </a:t>
+                  <a:t> in state </a:t>
                 </a:r>
                 <a14:m>
                   <m:oMath xmlns:m="http://schemas.openxmlformats.org/officeDocument/2006/math">
                     <m:r>
-                      <a:rPr lang="en-US" sz="1200" b="0" i="1" dirty="0" smtClean="0">
-                        <a:latin typeface="Cambria Math" panose="02040503050406030204" pitchFamily="18" charset="0"/>
-                      </a:rPr>
-                      <m:t>𝜋</m:t>
+                      <a:rPr lang="en-US" sz="1200" i="1" dirty="0">
+                        <a:latin typeface="Cambria Math" panose="02040503050406030204" pitchFamily="18" charset="0"/>
+                      </a:rPr>
+                      <m:t>𝑠</m:t>
                     </m:r>
                   </m:oMath>
                 </a14:m>
-                <a:endParaRPr lang="en-US" sz="1200" dirty="0"/>
+                <a:r>
+                  <a:rPr lang="en-US" sz="1200" dirty="0"/>
+                  <a:t> under stochastic policy </a:t>
+                </a:r>
+                <a14:m>
+                  <m:oMath xmlns:m="http://schemas.openxmlformats.org/officeDocument/2006/math">
+                    <m:r>
+                      <a:rPr lang="en-US" sz="1200" i="1" dirty="0">
+                        <a:latin typeface="Cambria Math" panose="02040503050406030204" pitchFamily="18" charset="0"/>
+                      </a:rPr>
+                      <m:t>𝜋</m:t>
+                    </m:r>
+                  </m:oMath>
+                </a14:m>
+                <a:endParaRPr lang="en-US" sz="1200" dirty="0">
+                  <a:ea typeface="Cambria Math" panose="02040503050406030204" pitchFamily="18" charset="0"/>
+                </a:endParaRPr>
               </a:p>
               <a:p>
                 <a:pPr marL="0" indent="0">
@@ -14999,7 +15653,7 @@
                 <a14:m>
                   <m:oMath xmlns:m="http://schemas.openxmlformats.org/officeDocument/2006/math">
                     <m:r>
-                      <a:rPr lang="en-US" sz="1200" b="0" i="1" dirty="0" smtClean="0">
+                      <a:rPr lang="en-US" sz="1200" i="1" dirty="0" smtClean="0">
                         <a:latin typeface="Cambria Math" panose="02040503050406030204" pitchFamily="18" charset="0"/>
                       </a:rPr>
                       <m:t>𝜋</m:t>
@@ -15011,25 +15665,13 @@
                       <m:t>(</m:t>
                     </m:r>
                     <m:r>
-                      <a:rPr lang="en-US" sz="1200" i="1" dirty="0" err="1">
-                        <a:latin typeface="Cambria Math" panose="02040503050406030204" pitchFamily="18" charset="0"/>
-                      </a:rPr>
-                      <m:t>𝑎</m:t>
-                    </m:r>
-                    <m:r>
-                      <a:rPr lang="en-US" sz="1200" i="1" dirty="0" err="1">
-                        <a:latin typeface="Cambria Math" panose="02040503050406030204" pitchFamily="18" charset="0"/>
-                      </a:rPr>
-                      <m:t>|</m:t>
-                    </m:r>
-                    <m:r>
-                      <a:rPr lang="en-US" sz="1200" i="1" dirty="0" err="1">
+                      <a:rPr lang="en-US" sz="1200" i="1" dirty="0" smtClean="0">
                         <a:latin typeface="Cambria Math" panose="02040503050406030204" pitchFamily="18" charset="0"/>
                       </a:rPr>
                       <m:t>𝑠</m:t>
                     </m:r>
                     <m:r>
-                      <a:rPr lang="en-US" sz="1200" i="1" dirty="0">
+                      <a:rPr lang="en-US" sz="1200" i="1" dirty="0" smtClean="0">
                         <a:latin typeface="Cambria Math" panose="02040503050406030204" pitchFamily="18" charset="0"/>
                       </a:rPr>
                       <m:t>)</m:t>
@@ -15038,7 +15680,7 @@
                 </a14:m>
                 <a:r>
                   <a:rPr lang="en-US" sz="1200" dirty="0"/>
-                  <a:t>	probability of taking action </a:t>
+                  <a:t>	action taken in state </a:t>
                 </a:r>
                 <a14:m>
                   <m:oMath xmlns:m="http://schemas.openxmlformats.org/officeDocument/2006/math">
@@ -15046,41 +15688,25 @@
                       <a:rPr lang="en-US" sz="1200" i="1" dirty="0" smtClean="0">
                         <a:latin typeface="Cambria Math" panose="02040503050406030204" pitchFamily="18" charset="0"/>
                       </a:rPr>
-                      <m:t>𝑎</m:t>
+                      <m:t>𝑠</m:t>
                     </m:r>
                   </m:oMath>
                 </a14:m>
                 <a:r>
                   <a:rPr lang="en-US" sz="1200" dirty="0"/>
-                  <a:t> in state </a:t>
+                  <a:t> under deterministic policy </a:t>
                 </a:r>
                 <a14:m>
                   <m:oMath xmlns:m="http://schemas.openxmlformats.org/officeDocument/2006/math">
                     <m:r>
-                      <a:rPr lang="en-US" sz="1200" i="1" dirty="0" smtClean="0">
-                        <a:latin typeface="Cambria Math" panose="02040503050406030204" pitchFamily="18" charset="0"/>
-                      </a:rPr>
-                      <m:t>𝑠</m:t>
+                      <a:rPr lang="en-US" sz="1200" b="0" i="1" dirty="0" smtClean="0">
+                        <a:latin typeface="Cambria Math" panose="02040503050406030204" pitchFamily="18" charset="0"/>
+                      </a:rPr>
+                      <m:t>𝜋</m:t>
                     </m:r>
                   </m:oMath>
                 </a14:m>
-                <a:r>
-                  <a:rPr lang="en-US" sz="1200" dirty="0"/>
-                  <a:t> under stochastic policy </a:t>
-                </a:r>
-                <a14:m>
-                  <m:oMath xmlns:m="http://schemas.openxmlformats.org/officeDocument/2006/math">
-                    <m:r>
-                      <a:rPr lang="en-US" sz="1200" b="0" i="1" dirty="0" smtClean="0">
-                        <a:latin typeface="Cambria Math" panose="02040503050406030204" pitchFamily="18" charset="0"/>
-                      </a:rPr>
-                      <m:t>𝜋</m:t>
-                    </m:r>
-                  </m:oMath>
-                </a14:m>
-                <a:endParaRPr lang="en-US" sz="1200" b="0" dirty="0">
-                  <a:ea typeface="Cambria Math" panose="02040503050406030204" pitchFamily="18" charset="0"/>
-                </a:endParaRPr>
+                <a:endParaRPr lang="en-US" sz="1200" dirty="0"/>
               </a:p>
             </p:txBody>
           </p:sp>
@@ -15102,8 +15728,8 @@
             </p:nvSpPr>
             <p:spPr>
               <a:xfrm>
-                <a:off x="822819" y="3291317"/>
-                <a:ext cx="5273179" cy="2309203"/>
+                <a:off x="822819" y="3570646"/>
+                <a:ext cx="5273179" cy="2985823"/>
               </a:xfrm>
               <a:prstGeom prst="rect">
                 <a:avLst/>
@@ -15111,806 +15737,7 @@
               <a:blipFill>
                 <a:blip r:embed="rId4"/>
                 <a:stretch>
-                  <a:fillRect t="-785"/>
-                </a:stretch>
-              </a:blipFill>
-            </p:spPr>
-            <p:txBody>
-              <a:bodyPr/>
-              <a:lstStyle/>
-              <a:p>
-                <a:r>
-                  <a:rPr lang="en-US">
-                    <a:noFill/>
-                  </a:rPr>
-                  <a:t> </a:t>
-                </a:r>
-              </a:p>
-            </p:txBody>
-          </p:sp>
-        </mc:Fallback>
-      </mc:AlternateContent>
-      <mc:AlternateContent xmlns:mc="http://schemas.openxmlformats.org/markup-compatibility/2006">
-        <mc:Choice xmlns:a14="http://schemas.microsoft.com/office/drawing/2010/main" Requires="a14">
-          <p:sp>
-            <p:nvSpPr>
-              <p:cNvPr id="4" name="Content Placeholder 2">
-                <a:extLst>
-                  <a:ext uri="{FF2B5EF4-FFF2-40B4-BE49-F238E27FC236}">
-                    <a16:creationId xmlns:a16="http://schemas.microsoft.com/office/drawing/2014/main" id="{CE78B3C3-4711-1AB7-B84A-8ADA6DA6F427}"/>
-                  </a:ext>
-                </a:extLst>
-              </p:cNvPr>
-              <p:cNvSpPr txBox="1">
-                <a:spLocks/>
-              </p:cNvSpPr>
-              <p:nvPr/>
-            </p:nvSpPr>
-            <p:spPr>
-              <a:xfrm>
-                <a:off x="6211474" y="2777480"/>
-                <a:ext cx="5273179" cy="759072"/>
-              </a:xfrm>
-              <a:prstGeom prst="rect">
-                <a:avLst/>
-              </a:prstGeom>
-            </p:spPr>
-            <p:style>
-              <a:lnRef idx="2">
-                <a:schemeClr val="accent2"/>
-              </a:lnRef>
-              <a:fillRef idx="1">
-                <a:schemeClr val="lt1"/>
-              </a:fillRef>
-              <a:effectRef idx="0">
-                <a:schemeClr val="accent2"/>
-              </a:effectRef>
-              <a:fontRef idx="minor">
-                <a:schemeClr val="dk1"/>
-              </a:fontRef>
-            </p:style>
-            <p:txBody>
-              <a:bodyPr vert="horz" lIns="91440" tIns="45720" rIns="91440" bIns="45720" rtlCol="0">
-                <a:noAutofit/>
-              </a:bodyPr>
-              <a:lstStyle>
-                <a:lvl1pPr marL="228600" indent="-228600" algn="l" defTabSz="914400" rtl="0" eaLnBrk="1" latinLnBrk="0" hangingPunct="1">
-                  <a:lnSpc>
-                    <a:spcPct val="90000"/>
-                  </a:lnSpc>
-                  <a:spcBef>
-                    <a:spcPts val="1000"/>
-                  </a:spcBef>
-                  <a:buFont typeface="Arial" panose="020B0604020202020204" pitchFamily="34" charset="0"/>
-                  <a:buChar char="•"/>
-                  <a:defRPr sz="2800" kern="1200">
-                    <a:solidFill>
-                      <a:schemeClr val="dk1"/>
-                    </a:solidFill>
-                    <a:latin typeface="+mn-lt"/>
-                    <a:ea typeface="+mn-ea"/>
-                    <a:cs typeface="+mn-cs"/>
-                  </a:defRPr>
-                </a:lvl1pPr>
-                <a:lvl2pPr marL="685800" indent="-228600" algn="l" defTabSz="914400" rtl="0" eaLnBrk="1" latinLnBrk="0" hangingPunct="1">
-                  <a:lnSpc>
-                    <a:spcPct val="90000"/>
-                  </a:lnSpc>
-                  <a:spcBef>
-                    <a:spcPts val="500"/>
-                  </a:spcBef>
-                  <a:buFont typeface="Arial" panose="020B0604020202020204" pitchFamily="34" charset="0"/>
-                  <a:buChar char="•"/>
-                  <a:defRPr sz="2400" kern="1200">
-                    <a:solidFill>
-                      <a:schemeClr val="dk1"/>
-                    </a:solidFill>
-                    <a:latin typeface="+mn-lt"/>
-                    <a:ea typeface="+mn-ea"/>
-                    <a:cs typeface="+mn-cs"/>
-                  </a:defRPr>
-                </a:lvl2pPr>
-                <a:lvl3pPr marL="1143000" indent="-228600" algn="l" defTabSz="914400" rtl="0" eaLnBrk="1" latinLnBrk="0" hangingPunct="1">
-                  <a:lnSpc>
-                    <a:spcPct val="90000"/>
-                  </a:lnSpc>
-                  <a:spcBef>
-                    <a:spcPts val="500"/>
-                  </a:spcBef>
-                  <a:buFont typeface="Arial" panose="020B0604020202020204" pitchFamily="34" charset="0"/>
-                  <a:buChar char="•"/>
-                  <a:defRPr sz="2000" kern="1200">
-                    <a:solidFill>
-                      <a:schemeClr val="dk1"/>
-                    </a:solidFill>
-                    <a:latin typeface="+mn-lt"/>
-                    <a:ea typeface="+mn-ea"/>
-                    <a:cs typeface="+mn-cs"/>
-                  </a:defRPr>
-                </a:lvl3pPr>
-                <a:lvl4pPr marL="1600200" indent="-228600" algn="l" defTabSz="914400" rtl="0" eaLnBrk="1" latinLnBrk="0" hangingPunct="1">
-                  <a:lnSpc>
-                    <a:spcPct val="90000"/>
-                  </a:lnSpc>
-                  <a:spcBef>
-                    <a:spcPts val="500"/>
-                  </a:spcBef>
-                  <a:buFont typeface="Arial" panose="020B0604020202020204" pitchFamily="34" charset="0"/>
-                  <a:buChar char="•"/>
-                  <a:defRPr sz="1800" kern="1200">
-                    <a:solidFill>
-                      <a:schemeClr val="dk1"/>
-                    </a:solidFill>
-                    <a:latin typeface="+mn-lt"/>
-                    <a:ea typeface="+mn-ea"/>
-                    <a:cs typeface="+mn-cs"/>
-                  </a:defRPr>
-                </a:lvl4pPr>
-                <a:lvl5pPr marL="2057400" indent="-228600" algn="l" defTabSz="914400" rtl="0" eaLnBrk="1" latinLnBrk="0" hangingPunct="1">
-                  <a:lnSpc>
-                    <a:spcPct val="90000"/>
-                  </a:lnSpc>
-                  <a:spcBef>
-                    <a:spcPts val="500"/>
-                  </a:spcBef>
-                  <a:buFont typeface="Arial" panose="020B0604020202020204" pitchFamily="34" charset="0"/>
-                  <a:buChar char="•"/>
-                  <a:defRPr sz="1800" kern="1200">
-                    <a:solidFill>
-                      <a:schemeClr val="dk1"/>
-                    </a:solidFill>
-                    <a:latin typeface="+mn-lt"/>
-                    <a:ea typeface="+mn-ea"/>
-                    <a:cs typeface="+mn-cs"/>
-                  </a:defRPr>
-                </a:lvl5pPr>
-                <a:lvl6pPr marL="2514600" indent="-228600" algn="l" defTabSz="914400" rtl="0" eaLnBrk="1" latinLnBrk="0" hangingPunct="1">
-                  <a:lnSpc>
-                    <a:spcPct val="90000"/>
-                  </a:lnSpc>
-                  <a:spcBef>
-                    <a:spcPts val="500"/>
-                  </a:spcBef>
-                  <a:buFont typeface="Arial" panose="020B0604020202020204" pitchFamily="34" charset="0"/>
-                  <a:buChar char="•"/>
-                  <a:defRPr sz="1800" kern="1200">
-                    <a:solidFill>
-                      <a:schemeClr val="dk1"/>
-                    </a:solidFill>
-                    <a:latin typeface="+mn-lt"/>
-                    <a:ea typeface="+mn-ea"/>
-                    <a:cs typeface="+mn-cs"/>
-                  </a:defRPr>
-                </a:lvl6pPr>
-                <a:lvl7pPr marL="2971800" indent="-228600" algn="l" defTabSz="914400" rtl="0" eaLnBrk="1" latinLnBrk="0" hangingPunct="1">
-                  <a:lnSpc>
-                    <a:spcPct val="90000"/>
-                  </a:lnSpc>
-                  <a:spcBef>
-                    <a:spcPts val="500"/>
-                  </a:spcBef>
-                  <a:buFont typeface="Arial" panose="020B0604020202020204" pitchFamily="34" charset="0"/>
-                  <a:buChar char="•"/>
-                  <a:defRPr sz="1800" kern="1200">
-                    <a:solidFill>
-                      <a:schemeClr val="dk1"/>
-                    </a:solidFill>
-                    <a:latin typeface="+mn-lt"/>
-                    <a:ea typeface="+mn-ea"/>
-                    <a:cs typeface="+mn-cs"/>
-                  </a:defRPr>
-                </a:lvl7pPr>
-                <a:lvl8pPr marL="3429000" indent="-228600" algn="l" defTabSz="914400" rtl="0" eaLnBrk="1" latinLnBrk="0" hangingPunct="1">
-                  <a:lnSpc>
-                    <a:spcPct val="90000"/>
-                  </a:lnSpc>
-                  <a:spcBef>
-                    <a:spcPts val="500"/>
-                  </a:spcBef>
-                  <a:buFont typeface="Arial" panose="020B0604020202020204" pitchFamily="34" charset="0"/>
-                  <a:buChar char="•"/>
-                  <a:defRPr sz="1800" kern="1200">
-                    <a:solidFill>
-                      <a:schemeClr val="dk1"/>
-                    </a:solidFill>
-                    <a:latin typeface="+mn-lt"/>
-                    <a:ea typeface="+mn-ea"/>
-                    <a:cs typeface="+mn-cs"/>
-                  </a:defRPr>
-                </a:lvl8pPr>
-                <a:lvl9pPr marL="3886200" indent="-228600" algn="l" defTabSz="914400" rtl="0" eaLnBrk="1" latinLnBrk="0" hangingPunct="1">
-                  <a:lnSpc>
-                    <a:spcPct val="90000"/>
-                  </a:lnSpc>
-                  <a:spcBef>
-                    <a:spcPts val="500"/>
-                  </a:spcBef>
-                  <a:buFont typeface="Arial" panose="020B0604020202020204" pitchFamily="34" charset="0"/>
-                  <a:buChar char="•"/>
-                  <a:defRPr sz="1800" kern="1200">
-                    <a:solidFill>
-                      <a:schemeClr val="dk1"/>
-                    </a:solidFill>
-                    <a:latin typeface="+mn-lt"/>
-                    <a:ea typeface="+mn-ea"/>
-                    <a:cs typeface="+mn-cs"/>
-                  </a:defRPr>
-                </a:lvl9pPr>
-              </a:lstStyle>
-              <a:p>
-                <a:pPr marL="0" indent="0">
-                  <a:spcBef>
-                    <a:spcPts val="0"/>
-                  </a:spcBef>
-                  <a:buNone/>
-                </a:pPr>
-                <a14:m>
-                  <m:oMath xmlns:m="http://schemas.openxmlformats.org/officeDocument/2006/math">
-                    <m:r>
-                      <a:rPr lang="en-US" sz="1200" i="1" dirty="0" smtClean="0">
-                        <a:solidFill>
-                          <a:schemeClr val="tx1"/>
-                        </a:solidFill>
-                        <a:latin typeface="Cambria Math" panose="02040503050406030204" pitchFamily="18" charset="0"/>
-                      </a:rPr>
-                      <m:t>𝑉</m:t>
-                    </m:r>
-                    <m:r>
-                      <a:rPr lang="en-US" sz="1200" i="1" dirty="0" smtClean="0">
-                        <a:solidFill>
-                          <a:schemeClr val="tx1"/>
-                        </a:solidFill>
-                        <a:latin typeface="Cambria Math" panose="02040503050406030204" pitchFamily="18" charset="0"/>
-                      </a:rPr>
-                      <m:t>, </m:t>
-                    </m:r>
-                    <m:sSub>
-                      <m:sSubPr>
-                        <m:ctrlPr>
-                          <a:rPr lang="en-US" sz="1200" b="0" i="1" dirty="0" smtClean="0">
-                            <a:solidFill>
-                              <a:schemeClr val="tx1"/>
-                            </a:solidFill>
-                            <a:latin typeface="Cambria Math" panose="02040503050406030204" pitchFamily="18" charset="0"/>
-                          </a:rPr>
-                        </m:ctrlPr>
-                      </m:sSubPr>
-                      <m:e>
-                        <m:r>
-                          <a:rPr lang="en-US" sz="1200" i="1" dirty="0" smtClean="0">
-                            <a:solidFill>
-                              <a:schemeClr val="tx1"/>
-                            </a:solidFill>
-                            <a:latin typeface="Cambria Math" panose="02040503050406030204" pitchFamily="18" charset="0"/>
-                          </a:rPr>
-                          <m:t>𝑉</m:t>
-                        </m:r>
-                      </m:e>
-                      <m:sub>
-                        <m:r>
-                          <a:rPr lang="en-US" sz="1200" i="1" dirty="0" smtClean="0">
-                            <a:solidFill>
-                              <a:schemeClr val="tx1"/>
-                            </a:solidFill>
-                            <a:latin typeface="Cambria Math" panose="02040503050406030204" pitchFamily="18" charset="0"/>
-                          </a:rPr>
-                          <m:t>𝑡</m:t>
-                        </m:r>
-                      </m:sub>
-                    </m:sSub>
-                    <m:r>
-                      <a:rPr lang="en-US" sz="1200" i="1" dirty="0" smtClean="0">
-                        <a:solidFill>
-                          <a:schemeClr val="tx1"/>
-                        </a:solidFill>
-                        <a:latin typeface="Cambria Math" panose="02040503050406030204" pitchFamily="18" charset="0"/>
-                      </a:rPr>
-                      <m:t> </m:t>
-                    </m:r>
-                  </m:oMath>
-                </a14:m>
-                <a:r>
-                  <a:rPr lang="en-US" sz="1200" dirty="0">
-                    <a:solidFill>
-                      <a:schemeClr val="tx1"/>
-                    </a:solidFill>
-                  </a:rPr>
-                  <a:t>	array estimates of state-value function </a:t>
-                </a:r>
-                <a14:m>
-                  <m:oMath xmlns:m="http://schemas.openxmlformats.org/officeDocument/2006/math">
-                    <m:sSub>
-                      <m:sSubPr>
-                        <m:ctrlPr>
-                          <a:rPr lang="en-US" sz="1200" b="0" i="1" dirty="0" smtClean="0">
-                            <a:solidFill>
-                              <a:schemeClr val="tx1"/>
-                            </a:solidFill>
-                            <a:latin typeface="Cambria Math" panose="02040503050406030204" pitchFamily="18" charset="0"/>
-                          </a:rPr>
-                        </m:ctrlPr>
-                      </m:sSubPr>
-                      <m:e>
-                        <m:r>
-                          <a:rPr lang="en-US" sz="1200" b="0" i="1" dirty="0" smtClean="0">
-                            <a:solidFill>
-                              <a:schemeClr val="tx1"/>
-                            </a:solidFill>
-                            <a:latin typeface="Cambria Math" panose="02040503050406030204" pitchFamily="18" charset="0"/>
-                          </a:rPr>
-                          <m:t>𝑣</m:t>
-                        </m:r>
-                      </m:e>
-                      <m:sub>
-                        <m:r>
-                          <a:rPr lang="en-US" sz="1200" b="0" i="1" dirty="0" smtClean="0">
-                            <a:solidFill>
-                              <a:schemeClr val="tx1"/>
-                            </a:solidFill>
-                            <a:latin typeface="Cambria Math" panose="02040503050406030204" pitchFamily="18" charset="0"/>
-                          </a:rPr>
-                          <m:t>𝜋</m:t>
-                        </m:r>
-                      </m:sub>
-                    </m:sSub>
-                    <m:r>
-                      <a:rPr lang="en-US" sz="1200" b="0" i="1" dirty="0" smtClean="0">
-                        <a:solidFill>
-                          <a:schemeClr val="tx1"/>
-                        </a:solidFill>
-                        <a:latin typeface="Cambria Math" panose="02040503050406030204" pitchFamily="18" charset="0"/>
-                      </a:rPr>
-                      <m:t> </m:t>
-                    </m:r>
-                  </m:oMath>
-                </a14:m>
-                <a:r>
-                  <a:rPr lang="en-US" sz="1200" dirty="0">
-                    <a:solidFill>
-                      <a:schemeClr val="tx1"/>
-                    </a:solidFill>
-                  </a:rPr>
-                  <a:t>or </a:t>
-                </a:r>
-                <a14:m>
-                  <m:oMath xmlns:m="http://schemas.openxmlformats.org/officeDocument/2006/math">
-                    <m:sSub>
-                      <m:sSubPr>
-                        <m:ctrlPr>
-                          <a:rPr lang="en-US" sz="1200" i="1" dirty="0">
-                            <a:solidFill>
-                              <a:schemeClr val="tx1"/>
-                            </a:solidFill>
-                            <a:latin typeface="Cambria Math" panose="02040503050406030204" pitchFamily="18" charset="0"/>
-                          </a:rPr>
-                        </m:ctrlPr>
-                      </m:sSubPr>
-                      <m:e>
-                        <m:r>
-                          <a:rPr lang="en-US" sz="1200" i="1" dirty="0">
-                            <a:solidFill>
-                              <a:schemeClr val="tx1"/>
-                            </a:solidFill>
-                            <a:latin typeface="Cambria Math" panose="02040503050406030204" pitchFamily="18" charset="0"/>
-                          </a:rPr>
-                          <m:t>𝑣</m:t>
-                        </m:r>
-                      </m:e>
-                      <m:sub>
-                        <m:r>
-                          <a:rPr lang="en-US" sz="1200" b="0" i="1" dirty="0" smtClean="0">
-                            <a:solidFill>
-                              <a:schemeClr val="tx1"/>
-                            </a:solidFill>
-                            <a:latin typeface="Cambria Math" panose="02040503050406030204" pitchFamily="18" charset="0"/>
-                          </a:rPr>
-                          <m:t>∗</m:t>
-                        </m:r>
-                      </m:sub>
-                    </m:sSub>
-                    <m:r>
-                      <a:rPr lang="en-US" sz="1200" i="1" dirty="0">
-                        <a:solidFill>
-                          <a:schemeClr val="tx1"/>
-                        </a:solidFill>
-                        <a:latin typeface="Cambria Math" panose="02040503050406030204" pitchFamily="18" charset="0"/>
-                      </a:rPr>
-                      <m:t> </m:t>
-                    </m:r>
-                  </m:oMath>
-                </a14:m>
-                <a:endParaRPr lang="en-US" sz="1200" dirty="0">
-                  <a:solidFill>
-                    <a:schemeClr val="tx1"/>
-                  </a:solidFill>
-                </a:endParaRPr>
-              </a:p>
-              <a:p>
-                <a:pPr marL="0" indent="0">
-                  <a:spcBef>
-                    <a:spcPts val="0"/>
-                  </a:spcBef>
-                  <a:buNone/>
-                </a:pPr>
-                <a14:m>
-                  <m:oMath xmlns:m="http://schemas.openxmlformats.org/officeDocument/2006/math">
-                    <m:r>
-                      <a:rPr lang="en-US" sz="1200" i="1" dirty="0" smtClean="0">
-                        <a:solidFill>
-                          <a:schemeClr val="tx1"/>
-                        </a:solidFill>
-                        <a:latin typeface="Cambria Math" panose="02040503050406030204" pitchFamily="18" charset="0"/>
-                      </a:rPr>
-                      <m:t>𝑄</m:t>
-                    </m:r>
-                    <m:r>
-                      <a:rPr lang="en-US" sz="1200" i="1" dirty="0" smtClean="0">
-                        <a:solidFill>
-                          <a:schemeClr val="tx1"/>
-                        </a:solidFill>
-                        <a:latin typeface="Cambria Math" panose="02040503050406030204" pitchFamily="18" charset="0"/>
-                      </a:rPr>
-                      <m:t>,</m:t>
-                    </m:r>
-                    <m:sSub>
-                      <m:sSubPr>
-                        <m:ctrlPr>
-                          <a:rPr lang="en-US" sz="1200" b="0" i="1" dirty="0" smtClean="0">
-                            <a:solidFill>
-                              <a:schemeClr val="tx1"/>
-                            </a:solidFill>
-                            <a:latin typeface="Cambria Math" panose="02040503050406030204" pitchFamily="18" charset="0"/>
-                          </a:rPr>
-                        </m:ctrlPr>
-                      </m:sSubPr>
-                      <m:e>
-                        <m:r>
-                          <a:rPr lang="en-US" sz="1200" i="1" dirty="0" smtClean="0">
-                            <a:solidFill>
-                              <a:schemeClr val="tx1"/>
-                            </a:solidFill>
-                            <a:latin typeface="Cambria Math" panose="02040503050406030204" pitchFamily="18" charset="0"/>
-                          </a:rPr>
-                          <m:t>𝑄</m:t>
-                        </m:r>
-                      </m:e>
-                      <m:sub>
-                        <m:r>
-                          <a:rPr lang="en-US" sz="1200" i="1" dirty="0" smtClean="0">
-                            <a:solidFill>
-                              <a:schemeClr val="tx1"/>
-                            </a:solidFill>
-                            <a:latin typeface="Cambria Math" panose="02040503050406030204" pitchFamily="18" charset="0"/>
-                          </a:rPr>
-                          <m:t>𝑡</m:t>
-                        </m:r>
-                      </m:sub>
-                    </m:sSub>
-                    <m:r>
-                      <a:rPr lang="en-US" sz="1200" i="1" dirty="0">
-                        <a:solidFill>
-                          <a:schemeClr val="tx1"/>
-                        </a:solidFill>
-                        <a:latin typeface="Cambria Math" panose="02040503050406030204" pitchFamily="18" charset="0"/>
-                      </a:rPr>
-                      <m:t> </m:t>
-                    </m:r>
-                  </m:oMath>
-                </a14:m>
-                <a:r>
-                  <a:rPr lang="en-US" sz="1200" dirty="0">
-                    <a:solidFill>
-                      <a:schemeClr val="tx1"/>
-                    </a:solidFill>
-                  </a:rPr>
-                  <a:t>	array estimates of action-value function </a:t>
-                </a:r>
-                <a14:m>
-                  <m:oMath xmlns:m="http://schemas.openxmlformats.org/officeDocument/2006/math">
-                    <m:sSub>
-                      <m:sSubPr>
-                        <m:ctrlPr>
-                          <a:rPr lang="en-US" sz="1200" i="1" dirty="0">
-                            <a:solidFill>
-                              <a:schemeClr val="tx1"/>
-                            </a:solidFill>
-                            <a:latin typeface="Cambria Math" panose="02040503050406030204" pitchFamily="18" charset="0"/>
-                          </a:rPr>
-                        </m:ctrlPr>
-                      </m:sSubPr>
-                      <m:e>
-                        <m:r>
-                          <a:rPr lang="en-US" sz="1200" b="0" i="1" dirty="0" smtClean="0">
-                            <a:solidFill>
-                              <a:schemeClr val="tx1"/>
-                            </a:solidFill>
-                            <a:latin typeface="Cambria Math" panose="02040503050406030204" pitchFamily="18" charset="0"/>
-                          </a:rPr>
-                          <m:t>𝑞</m:t>
-                        </m:r>
-                      </m:e>
-                      <m:sub>
-                        <m:r>
-                          <a:rPr lang="en-US" sz="1200" i="1" dirty="0">
-                            <a:solidFill>
-                              <a:schemeClr val="tx1"/>
-                            </a:solidFill>
-                            <a:latin typeface="Cambria Math" panose="02040503050406030204" pitchFamily="18" charset="0"/>
-                          </a:rPr>
-                          <m:t>𝜋</m:t>
-                        </m:r>
-                      </m:sub>
-                    </m:sSub>
-                    <m:r>
-                      <a:rPr lang="en-US" sz="1200" i="1" dirty="0">
-                        <a:solidFill>
-                          <a:schemeClr val="tx1"/>
-                        </a:solidFill>
-                        <a:latin typeface="Cambria Math" panose="02040503050406030204" pitchFamily="18" charset="0"/>
-                      </a:rPr>
-                      <m:t> </m:t>
-                    </m:r>
-                  </m:oMath>
-                </a14:m>
-                <a:r>
-                  <a:rPr lang="en-US" sz="1200" dirty="0">
-                    <a:solidFill>
-                      <a:schemeClr val="tx1"/>
-                    </a:solidFill>
-                  </a:rPr>
-                  <a:t>or </a:t>
-                </a:r>
-                <a14:m>
-                  <m:oMath xmlns:m="http://schemas.openxmlformats.org/officeDocument/2006/math">
-                    <m:sSub>
-                      <m:sSubPr>
-                        <m:ctrlPr>
-                          <a:rPr lang="en-US" sz="1200" i="1" dirty="0">
-                            <a:solidFill>
-                              <a:schemeClr val="tx1"/>
-                            </a:solidFill>
-                            <a:latin typeface="Cambria Math" panose="02040503050406030204" pitchFamily="18" charset="0"/>
-                          </a:rPr>
-                        </m:ctrlPr>
-                      </m:sSubPr>
-                      <m:e>
-                        <m:r>
-                          <a:rPr lang="en-US" sz="1200" i="1" dirty="0">
-                            <a:solidFill>
-                              <a:schemeClr val="tx1"/>
-                            </a:solidFill>
-                            <a:latin typeface="Cambria Math" panose="02040503050406030204" pitchFamily="18" charset="0"/>
-                          </a:rPr>
-                          <m:t>𝑣</m:t>
-                        </m:r>
-                      </m:e>
-                      <m:sub>
-                        <m:r>
-                          <a:rPr lang="en-US" sz="1200" b="0" i="1" dirty="0" smtClean="0">
-                            <a:solidFill>
-                              <a:schemeClr val="tx1"/>
-                            </a:solidFill>
-                            <a:latin typeface="Cambria Math" panose="02040503050406030204" pitchFamily="18" charset="0"/>
-                          </a:rPr>
-                          <m:t>∗</m:t>
-                        </m:r>
-                      </m:sub>
-                    </m:sSub>
-                  </m:oMath>
-                </a14:m>
-                <a:endParaRPr lang="en-US" sz="1200" dirty="0">
-                  <a:solidFill>
-                    <a:schemeClr val="tx1"/>
-                  </a:solidFill>
-                </a:endParaRPr>
-              </a:p>
-              <a:p>
-                <a:pPr marL="0" indent="0">
-                  <a:spcBef>
-                    <a:spcPts val="0"/>
-                  </a:spcBef>
-                  <a:buNone/>
-                </a:pPr>
-                <a14:m>
-                  <m:oMath xmlns:m="http://schemas.openxmlformats.org/officeDocument/2006/math">
-                    <m:sSub>
-                      <m:sSubPr>
-                        <m:ctrlPr>
-                          <a:rPr lang="en-US" sz="1200" b="0" i="1" dirty="0" smtClean="0">
-                            <a:solidFill>
-                              <a:schemeClr val="tx1"/>
-                            </a:solidFill>
-                            <a:latin typeface="Cambria Math" panose="02040503050406030204" pitchFamily="18" charset="0"/>
-                          </a:rPr>
-                        </m:ctrlPr>
-                      </m:sSubPr>
-                      <m:e>
-                        <m:acc>
-                          <m:accPr>
-                            <m:chr m:val="̅"/>
-                            <m:ctrlPr>
-                              <a:rPr lang="en-US" sz="1200" i="1" dirty="0" smtClean="0">
-                                <a:solidFill>
-                                  <a:schemeClr val="tx1"/>
-                                </a:solidFill>
-                                <a:latin typeface="Cambria Math" panose="02040503050406030204" pitchFamily="18" charset="0"/>
-                              </a:rPr>
-                            </m:ctrlPr>
-                          </m:accPr>
-                          <m:e>
-                            <m:r>
-                              <a:rPr lang="en-US" sz="1200" b="0" i="1" dirty="0" smtClean="0">
-                                <a:solidFill>
-                                  <a:schemeClr val="tx1"/>
-                                </a:solidFill>
-                                <a:latin typeface="Cambria Math" panose="02040503050406030204" pitchFamily="18" charset="0"/>
-                              </a:rPr>
-                              <m:t>𝑉</m:t>
-                            </m:r>
-                          </m:e>
-                        </m:acc>
-                      </m:e>
-                      <m:sub>
-                        <m:r>
-                          <a:rPr lang="en-US" sz="1200" b="0" i="1" dirty="0" smtClean="0">
-                            <a:solidFill>
-                              <a:schemeClr val="tx1"/>
-                            </a:solidFill>
-                            <a:latin typeface="Cambria Math" panose="02040503050406030204" pitchFamily="18" charset="0"/>
-                          </a:rPr>
-                          <m:t>𝑡</m:t>
-                        </m:r>
-                      </m:sub>
-                    </m:sSub>
-                    <m:r>
-                      <a:rPr lang="en-US" sz="1200" i="1" dirty="0">
-                        <a:solidFill>
-                          <a:schemeClr val="tx1"/>
-                        </a:solidFill>
-                        <a:latin typeface="Cambria Math" panose="02040503050406030204" pitchFamily="18" charset="0"/>
-                      </a:rPr>
-                      <m:t>(</m:t>
-                    </m:r>
-                    <m:r>
-                      <a:rPr lang="en-US" sz="1200" i="1" dirty="0">
-                        <a:solidFill>
-                          <a:schemeClr val="tx1"/>
-                        </a:solidFill>
-                        <a:latin typeface="Cambria Math" panose="02040503050406030204" pitchFamily="18" charset="0"/>
-                      </a:rPr>
-                      <m:t>𝑠</m:t>
-                    </m:r>
-                    <m:r>
-                      <a:rPr lang="en-US" sz="1200" i="1" dirty="0">
-                        <a:solidFill>
-                          <a:schemeClr val="tx1"/>
-                        </a:solidFill>
-                        <a:latin typeface="Cambria Math" panose="02040503050406030204" pitchFamily="18" charset="0"/>
-                      </a:rPr>
-                      <m:t>) </m:t>
-                    </m:r>
-                  </m:oMath>
-                </a14:m>
-                <a:r>
-                  <a:rPr lang="en-US" sz="1200" dirty="0">
-                    <a:solidFill>
-                      <a:schemeClr val="tx1"/>
-                    </a:solidFill>
-                  </a:rPr>
-                  <a:t>	expected approximate action value</a:t>
-                </a:r>
-              </a:p>
-              <a:p>
-                <a:pPr marL="0" indent="0">
-                  <a:spcBef>
-                    <a:spcPts val="0"/>
-                  </a:spcBef>
-                  <a:buNone/>
-                </a:pPr>
-                <a14:m>
-                  <m:oMath xmlns:m="http://schemas.openxmlformats.org/officeDocument/2006/math">
-                    <m:sSub>
-                      <m:sSubPr>
-                        <m:ctrlPr>
-                          <a:rPr lang="en-US" sz="1200" b="0" i="1" dirty="0" smtClean="0">
-                            <a:solidFill>
-                              <a:schemeClr val="tx1"/>
-                            </a:solidFill>
-                            <a:latin typeface="Cambria Math" panose="02040503050406030204" pitchFamily="18" charset="0"/>
-                          </a:rPr>
-                        </m:ctrlPr>
-                      </m:sSubPr>
-                      <m:e>
-                        <m:r>
-                          <a:rPr lang="en-US" sz="1200" i="1" dirty="0" smtClean="0">
-                            <a:solidFill>
-                              <a:schemeClr val="tx1"/>
-                            </a:solidFill>
-                            <a:latin typeface="Cambria Math" panose="02040503050406030204" pitchFamily="18" charset="0"/>
-                          </a:rPr>
-                          <m:t>𝑈</m:t>
-                        </m:r>
-                      </m:e>
-                      <m:sub>
-                        <m:r>
-                          <a:rPr lang="en-US" sz="1200" i="1" dirty="0" smtClean="0">
-                            <a:solidFill>
-                              <a:schemeClr val="tx1"/>
-                            </a:solidFill>
-                            <a:latin typeface="Cambria Math" panose="02040503050406030204" pitchFamily="18" charset="0"/>
-                          </a:rPr>
-                          <m:t>𝑡</m:t>
-                        </m:r>
-                      </m:sub>
-                    </m:sSub>
-                  </m:oMath>
-                </a14:m>
-                <a:r>
-                  <a:rPr lang="en-US" sz="1200" dirty="0">
-                    <a:solidFill>
-                      <a:schemeClr val="tx1"/>
-                    </a:solidFill>
-                  </a:rPr>
-                  <a:t>	target for estimate at time</a:t>
-                </a:r>
-                <a14:m>
-                  <m:oMath xmlns:m="http://schemas.openxmlformats.org/officeDocument/2006/math">
-                    <m:r>
-                      <a:rPr lang="en-US" sz="1200" i="1" dirty="0" smtClean="0">
-                        <a:solidFill>
-                          <a:schemeClr val="tx1"/>
-                        </a:solidFill>
-                        <a:latin typeface="Cambria Math" panose="02040503050406030204" pitchFamily="18" charset="0"/>
-                      </a:rPr>
-                      <m:t> </m:t>
-                    </m:r>
-                    <m:r>
-                      <a:rPr lang="en-US" sz="1200" i="1" dirty="0" smtClean="0">
-                        <a:solidFill>
-                          <a:schemeClr val="tx1"/>
-                        </a:solidFill>
-                        <a:latin typeface="Cambria Math" panose="02040503050406030204" pitchFamily="18" charset="0"/>
-                      </a:rPr>
-                      <m:t>𝑡</m:t>
-                    </m:r>
-                  </m:oMath>
-                </a14:m>
-                <a:endParaRPr lang="en-US" sz="1200" dirty="0">
-                  <a:solidFill>
-                    <a:schemeClr val="tx1"/>
-                  </a:solidFill>
-                </a:endParaRPr>
-              </a:p>
-            </p:txBody>
-          </p:sp>
-        </mc:Choice>
-        <mc:Fallback>
-          <p:sp>
-            <p:nvSpPr>
-              <p:cNvPr id="4" name="Content Placeholder 2">
-                <a:extLst>
-                  <a:ext uri="{FF2B5EF4-FFF2-40B4-BE49-F238E27FC236}">
-                    <a16:creationId xmlns:a16="http://schemas.microsoft.com/office/drawing/2014/main" id="{CE78B3C3-4711-1AB7-B84A-8ADA6DA6F427}"/>
-                  </a:ext>
-                </a:extLst>
-              </p:cNvPr>
-              <p:cNvSpPr txBox="1">
-                <a:spLocks noRot="1" noChangeAspect="1" noMove="1" noResize="1" noEditPoints="1" noAdjustHandles="1" noChangeArrowheads="1" noChangeShapeType="1" noTextEdit="1"/>
-              </p:cNvSpPr>
-              <p:nvPr/>
-            </p:nvSpPr>
-            <p:spPr>
-              <a:xfrm>
-                <a:off x="6211474" y="2777480"/>
-                <a:ext cx="5273179" cy="759072"/>
-              </a:xfrm>
-              <a:prstGeom prst="rect">
-                <a:avLst/>
-              </a:prstGeom>
-              <a:blipFill>
-                <a:blip r:embed="rId5"/>
-                <a:stretch>
-                  <a:fillRect t="-2362" b="-3937"/>
+                  <a:fillRect t="-609"/>
                 </a:stretch>
               </a:blipFill>
             </p:spPr>
@@ -15932,7 +15759,7 @@
     </p:spTree>
     <p:extLst>
       <p:ext uri="{BB962C8B-B14F-4D97-AF65-F5344CB8AC3E}">
-        <p14:creationId xmlns:p14="http://schemas.microsoft.com/office/powerpoint/2010/main" val="3187278720"/>
+        <p14:creationId xmlns:p14="http://schemas.microsoft.com/office/powerpoint/2010/main" val="2575471504"/>
       </p:ext>
     </p:extLst>
   </p:cSld>
@@ -18157,31 +17984,38 @@
           </a:p>
         </p:txBody>
       </p:sp>
-      <p:sp>
-        <p:nvSpPr>
-          <p:cNvPr id="3" name="Content Placeholder 2">
+      <p:pic>
+        <p:nvPicPr>
+          <p:cNvPr id="5" name="Content Placeholder 4">
             <a:extLst>
               <a:ext uri="{FF2B5EF4-FFF2-40B4-BE49-F238E27FC236}">
-                <a16:creationId xmlns:a16="http://schemas.microsoft.com/office/drawing/2014/main" id="{E3ABDABF-BEAE-4EDA-2F1C-4D52EFE2C1DD}"/>
+                <a16:creationId xmlns:a16="http://schemas.microsoft.com/office/drawing/2014/main" id="{3DFAADF1-3BAF-1C5B-A7CB-DDA430778E61}"/>
               </a:ext>
             </a:extLst>
           </p:cNvPr>
-          <p:cNvSpPr>
-            <a:spLocks noGrp="1"/>
-          </p:cNvSpPr>
+          <p:cNvPicPr>
+            <a:picLocks noGrp="1" noChangeAspect="1"/>
+          </p:cNvPicPr>
           <p:nvPr>
             <p:ph idx="1"/>
           </p:nvPr>
-        </p:nvSpPr>
-        <p:spPr/>
-        <p:txBody>
-          <a:bodyPr/>
-          <a:lstStyle/>
-          <a:p>
-            <a:endParaRPr lang="en-US" dirty="0"/>
-          </a:p>
-        </p:txBody>
-      </p:sp>
+        </p:nvPicPr>
+        <p:blipFill>
+          <a:blip r:embed="rId2"/>
+          <a:stretch>
+            <a:fillRect/>
+          </a:stretch>
+        </p:blipFill>
+        <p:spPr>
+          <a:xfrm>
+            <a:off x="1894912" y="5442913"/>
+            <a:ext cx="8059275" cy="819264"/>
+          </a:xfrm>
+          <a:prstGeom prst="rect">
+            <a:avLst/>
+          </a:prstGeom>
+        </p:spPr>
+      </p:pic>
       <p:pic>
         <p:nvPicPr>
           <p:cNvPr id="7" name="Picture 6">
@@ -18197,7 +18031,7 @@
           <p:nvPr/>
         </p:nvPicPr>
         <p:blipFill>
-          <a:blip r:embed="rId2"/>
+          <a:blip r:embed="rId3"/>
           <a:stretch>
             <a:fillRect/>
           </a:stretch>

</xml_diff>